<commit_message>
docs(presentation): embed app screenshots and live system callout cards into SIH idea presentation deck and PDF
</commit_message>
<xml_diff>
--- a/KisanSetu-AI_SIH2026_Presentation.pptx
+++ b/KisanSetu-AI_SIH2026_Presentation.pptx
@@ -5,7 +5,7 @@
     <p:sldMasterId id="2147483648" r:id="rId1"/>
   </p:sldMasterIdLst>
   <p:notesMasterIdLst>
-    <p:notesMasterId r:id="rId9"/>
+    <p:notesMasterId r:id="rId8"/>
   </p:notesMasterIdLst>
   <p:sldIdLst>
     <p:sldId id="291" r:id="rId2"/>
@@ -261,7 +261,7 @@
             <a:fld id="{C4D5ADD5-2BBC-4A94-8F86-D9013941F742}" type="datetimeFigureOut">
               <a:rPr lang="en-US"/>
               <a:pPr/>
-              <a:t>6/2/2026</a:t>
+              <a:t>9/7/2026</a:t>
             </a:fld>
             <a:endParaRPr lang="en-US"/>
           </a:p>
@@ -1351,184 +1351,6 @@
 </p:notes>
 </file>
 
-<file path=ppt/notesSlides/notesSlide6.xml><?xml version="1.0" encoding="utf-8"?>
-<p:notes xmlns:a="http://schemas.openxmlformats.org/drawingml/2006/main" xmlns:r="http://schemas.openxmlformats.org/officeDocument/2006/relationships" xmlns:p="http://schemas.openxmlformats.org/presentationml/2006/main">
-  <p:cSld>
-    <p:spTree>
-      <p:nvGrpSpPr>
-        <p:cNvPr id="1" name=""/>
-        <p:cNvGrpSpPr/>
-        <p:nvPr/>
-      </p:nvGrpSpPr>
-      <p:grpSpPr>
-        <a:xfrm>
-          <a:off x="0" y="0"/>
-          <a:ext cx="0" cy="0"/>
-          <a:chOff x="0" y="0"/>
-          <a:chExt cx="0" cy="0"/>
-        </a:xfrm>
-      </p:grpSpPr>
-      <p:sp>
-        <p:nvSpPr>
-          <p:cNvPr id="18433" name="Slide Image Placeholder 1"/>
-          <p:cNvSpPr>
-            <a:spLocks noGrp="1" noRot="1" noChangeAspect="1"/>
-          </p:cNvSpPr>
-          <p:nvPr>
-            <p:ph type="sldImg"/>
-          </p:nvPr>
-        </p:nvSpPr>
-        <p:spPr bwMode="auto">
-          <a:xfrm>
-            <a:off x="381000" y="685800"/>
-            <a:ext cx="6096000" cy="3429000"/>
-          </a:xfrm>
-          <a:noFill/>
-          <a:ln>
-            <a:solidFill>
-              <a:srgbClr val="000000"/>
-            </a:solidFill>
-            <a:miter lim="800000"/>
-            <a:headEnd/>
-            <a:tailEnd/>
-          </a:ln>
-        </p:spPr>
-      </p:sp>
-      <p:sp>
-        <p:nvSpPr>
-          <p:cNvPr id="18434" name="Notes Placeholder 2"/>
-          <p:cNvSpPr>
-            <a:spLocks noGrp="1"/>
-          </p:cNvSpPr>
-          <p:nvPr>
-            <p:ph type="body" idx="1"/>
-          </p:nvPr>
-        </p:nvSpPr>
-        <p:spPr bwMode="auto">
-          <a:noFill/>
-        </p:spPr>
-        <p:txBody>
-          <a:bodyPr wrap="square" numCol="1" anchor="t" anchorCtr="0" compatLnSpc="1">
-            <a:prstTxWarp prst="textNoShape">
-              <a:avLst/>
-            </a:prstTxWarp>
-          </a:bodyPr>
-          <a:lstStyle/>
-          <a:p>
-            <a:pPr eaLnBrk="1" hangingPunct="1">
-              <a:spcBef>
-                <a:spcPct val="0"/>
-              </a:spcBef>
-            </a:pPr>
-            <a:endParaRPr lang="en-US">
-              <a:ea typeface="ＭＳ Ｐゴシック" pitchFamily="1" charset="-128"/>
-            </a:endParaRPr>
-          </a:p>
-        </p:txBody>
-      </p:sp>
-      <p:sp>
-        <p:nvSpPr>
-          <p:cNvPr id="18435" name="Slide Number Placeholder 3"/>
-          <p:cNvSpPr>
-            <a:spLocks noGrp="1"/>
-          </p:cNvSpPr>
-          <p:nvPr>
-            <p:ph type="sldNum" sz="quarter" idx="5"/>
-          </p:nvPr>
-        </p:nvSpPr>
-        <p:spPr bwMode="auto">
-          <a:noFill/>
-          <a:ln>
-            <a:miter lim="800000"/>
-            <a:headEnd/>
-            <a:tailEnd/>
-          </a:ln>
-        </p:spPr>
-        <p:txBody>
-          <a:bodyPr/>
-          <a:lstStyle/>
-          <a:p>
-            <a:pPr marL="0" marR="0" lvl="0" indent="0" algn="r" defTabSz="457200" rtl="0" eaLnBrk="1" fontAlgn="base" latinLnBrk="0" hangingPunct="1">
-              <a:lnSpc>
-                <a:spcPct val="100000"/>
-              </a:lnSpc>
-              <a:spcBef>
-                <a:spcPct val="0"/>
-              </a:spcBef>
-              <a:spcAft>
-                <a:spcPct val="0"/>
-              </a:spcAft>
-              <a:buClrTx/>
-              <a:buSzTx/>
-              <a:buFontTx/>
-              <a:buNone/>
-              <a:tabLst/>
-              <a:defRPr/>
-            </a:pPr>
-            <a:fld id="{0CA7B74D-3791-4AC6-8451-F10DBCCCDD9A}" type="slidenum">
-              <a:rPr kumimoji="0" lang="en-US" sz="1200" b="0" i="0" u="none" strike="noStrike" kern="1200" cap="none" spc="0" normalizeH="0" baseline="0" noProof="0">
-                <a:ln>
-                  <a:noFill/>
-                </a:ln>
-                <a:solidFill>
-                  <a:prstClr val="black"/>
-                </a:solidFill>
-                <a:effectLst/>
-                <a:uLnTx/>
-                <a:uFillTx/>
-                <a:latin typeface="Calibri" pitchFamily="34" charset="0"/>
-                <a:ea typeface="ＭＳ Ｐゴシック" pitchFamily="1" charset="-128"/>
-                <a:cs typeface="+mn-cs"/>
-              </a:rPr>
-              <a:pPr marL="0" marR="0" lvl="0" indent="0" algn="r" defTabSz="457200" rtl="0" eaLnBrk="1" fontAlgn="base" latinLnBrk="0" hangingPunct="1">
-                <a:lnSpc>
-                  <a:spcPct val="100000"/>
-                </a:lnSpc>
-                <a:spcBef>
-                  <a:spcPct val="0"/>
-                </a:spcBef>
-                <a:spcAft>
-                  <a:spcPct val="0"/>
-                </a:spcAft>
-                <a:buClrTx/>
-                <a:buSzTx/>
-                <a:buFontTx/>
-                <a:buNone/>
-                <a:tabLst/>
-                <a:defRPr/>
-              </a:pPr>
-              <a:t>7</a:t>
-            </a:fld>
-            <a:endParaRPr kumimoji="0" lang="en-US" sz="1200" b="0" i="0" u="none" strike="noStrike" kern="1200" cap="none" spc="0" normalizeH="0" baseline="0" noProof="0">
-              <a:ln>
-                <a:noFill/>
-              </a:ln>
-              <a:solidFill>
-                <a:prstClr val="black"/>
-              </a:solidFill>
-              <a:effectLst/>
-              <a:uLnTx/>
-              <a:uFillTx/>
-              <a:latin typeface="Calibri" pitchFamily="34" charset="0"/>
-              <a:ea typeface="ＭＳ Ｐゴシック" pitchFamily="1" charset="-128"/>
-              <a:cs typeface="+mn-cs"/>
-            </a:endParaRPr>
-          </a:p>
-        </p:txBody>
-      </p:sp>
-    </p:spTree>
-    <p:extLst>
-      <p:ext uri="{BB962C8B-B14F-4D97-AF65-F5344CB8AC3E}">
-        <p14:creationId xmlns:p14="http://schemas.microsoft.com/office/powerpoint/2010/main" val="3783576877"/>
-      </p:ext>
-    </p:extLst>
-  </p:cSld>
-  <p:clrMapOvr>
-    <a:masterClrMapping/>
-  </p:clrMapOvr>
-</p:notes>
-</file>
-
 <file path=ppt/slideLayouts/slideLayout1.xml><?xml version="1.0" encoding="utf-8"?>
 <p:sldLayout xmlns:a="http://schemas.openxmlformats.org/drawingml/2006/main" xmlns:r="http://schemas.openxmlformats.org/officeDocument/2006/relationships" xmlns:p="http://schemas.openxmlformats.org/presentationml/2006/main" type="title" preserve="1">
   <p:cSld name="Title Slide">
@@ -1712,7 +1534,7 @@
           <a:p>
             <a:fld id="{E60792E3-D524-454C-8AFD-A91972900BCB}" type="datetime1">
               <a:rPr lang="en-US" smtClean="0"/>
-              <a:t>6/2/2026</a:t>
+              <a:t>9/7/2026</a:t>
             </a:fld>
             <a:endParaRPr lang="en-US"/>
           </a:p>
@@ -1894,7 +1716,7 @@
           <a:p>
             <a:fld id="{053C3A68-6922-42D3-8905-ECC2D82A3469}" type="datetime1">
               <a:rPr lang="en-US" smtClean="0"/>
-              <a:t>6/2/2026</a:t>
+              <a:t>9/7/2026</a:t>
             </a:fld>
             <a:endParaRPr lang="en-US"/>
           </a:p>
@@ -2086,7 +1908,7 @@
           <a:p>
             <a:fld id="{CB69E9F4-7604-4950-A8B2-8ACDEDB1506E}" type="datetime1">
               <a:rPr lang="en-US" smtClean="0"/>
-              <a:t>6/2/2026</a:t>
+              <a:t>9/7/2026</a:t>
             </a:fld>
             <a:endParaRPr lang="en-US"/>
           </a:p>
@@ -2268,7 +2090,7 @@
           <a:p>
             <a:fld id="{708B7524-32A2-4C20-A58C-BC3BAA1042FC}" type="datetime1">
               <a:rPr lang="en-US" smtClean="0"/>
-              <a:t>6/2/2026</a:t>
+              <a:t>9/7/2026</a:t>
             </a:fld>
             <a:endParaRPr lang="en-US"/>
           </a:p>
@@ -2527,7 +2349,7 @@
           <a:p>
             <a:fld id="{1E994447-D6B2-43BB-A877-57F1A267B999}" type="datetime1">
               <a:rPr lang="en-US" smtClean="0"/>
-              <a:t>6/2/2026</a:t>
+              <a:t>9/7/2026</a:t>
             </a:fld>
             <a:endParaRPr lang="en-US"/>
           </a:p>
@@ -2826,7 +2648,7 @@
           <a:p>
             <a:fld id="{68920E16-BD35-483C-AA6B-346FC7E46DEA}" type="datetime1">
               <a:rPr lang="en-US" smtClean="0"/>
-              <a:t>6/2/2026</a:t>
+              <a:t>9/7/2026</a:t>
             </a:fld>
             <a:endParaRPr lang="en-US"/>
           </a:p>
@@ -3259,7 +3081,7 @@
           <a:p>
             <a:fld id="{2FEAC6F8-5103-4FC0-A69E-5C6AE6469DA8}" type="datetime1">
               <a:rPr lang="en-US" smtClean="0"/>
-              <a:t>6/2/2026</a:t>
+              <a:t>9/7/2026</a:t>
             </a:fld>
             <a:endParaRPr lang="en-US"/>
           </a:p>
@@ -3390,7 +3212,7 @@
           <a:p>
             <a:fld id="{C60C6921-0627-4C8F-83D5-0CF936D2FFDD}" type="datetime1">
               <a:rPr lang="en-US" smtClean="0"/>
-              <a:t>6/2/2026</a:t>
+              <a:t>9/7/2026</a:t>
             </a:fld>
             <a:endParaRPr lang="en-US"/>
           </a:p>
@@ -3499,7 +3321,7 @@
           <a:p>
             <a:fld id="{2FF08AD7-8103-40F8-983C-E2BA6BB9CBE0}" type="datetime1">
               <a:rPr lang="en-US" smtClean="0"/>
-              <a:t>6/2/2026</a:t>
+              <a:t>9/7/2026</a:t>
             </a:fld>
             <a:endParaRPr lang="en-US"/>
           </a:p>
@@ -3788,7 +3610,7 @@
           <a:p>
             <a:fld id="{DF8C06B4-9380-4A4D-AF49-A3596E17DAF5}" type="datetime1">
               <a:rPr lang="en-US" smtClean="0"/>
-              <a:t>6/2/2026</a:t>
+              <a:t>9/7/2026</a:t>
             </a:fld>
             <a:endParaRPr lang="en-US"/>
           </a:p>
@@ -4057,7 +3879,7 @@
           <a:p>
             <a:fld id="{EF7FDEF1-C582-4E22-9E77-D68326471F28}" type="datetime1">
               <a:rPr lang="en-US" smtClean="0"/>
-              <a:t>6/2/2026</a:t>
+              <a:t>9/7/2026</a:t>
             </a:fld>
             <a:endParaRPr lang="en-US"/>
           </a:p>
@@ -4300,7 +4122,7 @@
           <a:p>
             <a:fld id="{780A9602-A9A9-453F-AEF1-37B5837E02CD}" type="datetime1">
               <a:rPr lang="en-US" smtClean="0"/>
-              <a:t>6/2/2026</a:t>
+              <a:t>9/7/2026</a:t>
             </a:fld>
             <a:endParaRPr lang="en-US"/>
           </a:p>
@@ -4851,7 +4673,7 @@
                 <a16:creationId xmlns:a16="http://schemas.microsoft.com/office/drawing/2014/main" id="{3E443FD7-A66B-4AA0-872D-B088B9BC5F17}"/>
               </a:ext>
               <a:ext uri="{C183D7F6-B498-43B3-948B-1728B52AA6E4}">
-                <adec:decorative xmlns:adec="http://schemas.microsoft.com/office/drawing/2017/decorative" xmlns="" val="1"/>
+                <adec:decorative xmlns:adec="http://schemas.microsoft.com/office/drawing/2017/decorative" val="1"/>
               </a:ext>
             </a:extLst>
           </p:cNvPr>
@@ -4911,7 +4733,7 @@
                 <a16:creationId xmlns:a16="http://schemas.microsoft.com/office/drawing/2014/main" id="{C04BE0EF-3561-49B4-9A29-F283168A91C7}"/>
               </a:ext>
               <a:ext uri="{C183D7F6-B498-43B3-948B-1728B52AA6E4}">
-                <adec:decorative xmlns:adec="http://schemas.microsoft.com/office/drawing/2017/decorative" xmlns="" val="1"/>
+                <adec:decorative xmlns:adec="http://schemas.microsoft.com/office/drawing/2017/decorative" val="1"/>
               </a:ext>
             </a:extLst>
           </p:cNvPr>
@@ -5768,7 +5590,7 @@
         <p:spPr>
           <a:xfrm>
             <a:off x="331286" y="-526757"/>
-            <a:ext cx="10363200" cy="2076450"/>
+            <a:ext cx="9280000" cy="2076450"/>
           </a:xfrm>
         </p:spPr>
         <p:txBody>
@@ -5782,16 +5604,7 @@
                 </a:solidFill>
                 <a:latin typeface="Garamond" panose="02020404030301010803" pitchFamily="18" charset="0"/>
               </a:rPr>
-              <a:t>SMART INDIA HACKATHON </a:t>
-            </a:r>
-            <a:r>
-              <a:rPr lang="en-US" sz="4000" b="1" dirty="0" smtClean="0">
-                <a:solidFill>
-                  <a:schemeClr val="tx2"/>
-                </a:solidFill>
-                <a:latin typeface="Garamond" panose="02020404030301010803" pitchFamily="18" charset="0"/>
-              </a:rPr>
-              <a:t>2026</a:t>
+              <a:t>SMART INDIA HACKATHON 2026</a:t>
             </a:r>
             <a:endParaRPr lang="en-IN" sz="4000" b="1" dirty="0">
               <a:solidFill>
@@ -5811,7 +5624,7 @@
         <p:spPr>
           <a:xfrm>
             <a:off x="331286" y="2076450"/>
-            <a:ext cx="5924550" cy="4703019"/>
+            <a:ext cx="5924550" cy="2185214"/>
           </a:xfrm>
           <a:prstGeom prst="rect">
             <a:avLst/>
@@ -5825,39 +5638,59 @@
           <a:lstStyle/>
           <a:p>
             <a:r>
+              <a:rPr sz="2000" b="1" dirty="0"/>
+              <a:t>Problem Statement ID – 26032</a:t>
+            </a:r>
+            <a:endParaRPr lang="en-US" dirty="0"/>
+          </a:p>
+          <a:p>
+            <a:r>
+              <a:rPr sz="1800" b="1" dirty="0"/>
+              <a:t>Problem Statement Title – Smart Procurement Management for Govt. Mandis</a:t>
+            </a:r>
+          </a:p>
+          <a:p>
+            <a:r>
+              <a:rPr sz="2000" b="1" dirty="0"/>
+              <a:t>Theme – Smart Automation</a:t>
+            </a:r>
+          </a:p>
+          <a:p>
+            <a:r>
+              <a:rPr sz="2000" b="1" dirty="0"/>
+              <a:t>PS Category – Software</a:t>
+            </a:r>
+          </a:p>
+          <a:p>
+            <a:r>
+              <a:rPr sz="2000" b="1" dirty="0"/>
+              <a:t>Team ID </a:t>
+            </a:r>
+            <a:r>
               <a:rPr sz="2000" b="1"/>
-              <a:t>Problem Statement ID – 26032</a:t>
-            </a:r>
-            <a:endParaRPr lang="en-US" dirty="0"/>
-          </a:p>
-          <a:p>
-            <a:r>
-              <a:rPr sz="1800" b="1"/>
-              <a:t>Problem Statement Title – Smart Procurement Management for Govt. Mandis</a:t>
+              <a:t>– </a:t>
+            </a:r>
+            <a:r>
+              <a:rPr lang="en-US" sz="2000"/>
+              <a:t>SIH2026-APP-7729</a:t>
             </a:r>
           </a:p>
           <a:p>
             <a:r>
               <a:rPr sz="2000" b="1"/>
-              <a:t>Theme – Smart Automation</a:t>
-            </a:r>
-          </a:p>
-          <a:p>
-            <a:r>
-              <a:rPr sz="2000" b="1"/>
-              <a:t>PS Category – Software</a:t>
-            </a:r>
-          </a:p>
-          <a:p>
-            <a:r>
-              <a:rPr sz="2000" b="1"/>
-              <a:t>Team ID – [As on SIH Portal]</a:t>
-            </a:r>
-          </a:p>
-          <a:p>
-            <a:r>
-              <a:rPr sz="2000" b="1"/>
-              <a:t>Team Name – KisanSetu AI</a:t>
+              <a:t>Team </a:t>
+            </a:r>
+            <a:r>
+              <a:rPr sz="2000" b="1" dirty="0"/>
+              <a:t>Name – </a:t>
+            </a:r>
+            <a:r>
+              <a:rPr sz="2000" b="1" dirty="0" err="1"/>
+              <a:t>KisanSetu</a:t>
+            </a:r>
+            <a:r>
+              <a:rPr sz="2000" b="1" dirty="0"/>
+              <a:t> AI</a:t>
             </a:r>
           </a:p>
         </p:txBody>
@@ -5987,8 +5820,8 @@
         </p:nvSpPr>
         <p:spPr>
           <a:xfrm>
-            <a:off x="182998" y="0"/>
-            <a:ext cx="10972800" cy="1143000"/>
+            <a:off x="1700000" y="0"/>
+            <a:ext cx="7930000" cy="1143000"/>
           </a:xfrm>
         </p:spPr>
         <p:txBody>
@@ -5997,7 +5830,7 @@
           <a:p>
             <a:pPr eaLnBrk="1" hangingPunct="1"/>
             <a:r>
-              <a:rPr sz="3600" b="1"/>
+              <a:rPr sz="3000" b="1"/>
               <a:t>KisanSetu AI — Smart Procurement Management</a:t>
             </a:r>
           </a:p>
@@ -6013,8 +5846,8 @@
         </p:nvSpPr>
         <p:spPr bwMode="auto">
           <a:xfrm>
-            <a:off x="-1" y="2064921"/>
-            <a:ext cx="12191999" cy="2492990"/>
+            <a:off x="612648" y="1188720"/>
+            <a:ext cx="6080760" cy="4846320"/>
           </a:xfrm>
           <a:prstGeom prst="rect">
             <a:avLst/>
@@ -6036,9 +5869,10 @@
             <a:pPr marL="342900" indent="-342900">
               <a:buFont typeface="Wingdings" panose="05000000000000000000" pitchFamily="2" charset="2"/>
               <a:buChar char="v"/>
-              <a:defRPr sz="2600" b="1"/>
-            </a:pPr>
-            <a:r>
+              <a:defRPr sz="2400" b="1"/>
+            </a:pPr>
+            <a:r>
+              <a:rPr sz="2000" b="1"/>
               <a:t>Proposed Solution</a:t>
             </a:r>
             <a:endParaRPr lang="en-US" sz="3200" u="sng" dirty="0">
@@ -6051,83 +5885,100 @@
           </a:p>
           <a:p>
             <a:pPr>
-              <a:defRPr sz="1000" b="0"/>
-            </a:pPr>
+              <a:defRPr sz="700" b="0"/>
+            </a:pPr>
+            <a:endParaRPr lang="en-US" sz="3200" u="sng" dirty="0">
+              <a:solidFill>
+                <a:schemeClr val="tx2"/>
+              </a:solidFill>
+              <a:latin typeface="Arial" pitchFamily="34" charset="0"/>
+              <a:cs typeface="Arial" pitchFamily="34" charset="0"/>
+            </a:endParaRPr>
           </a:p>
           <a:p>
             <a:pPr>
-              <a:defRPr sz="1950" b="0"/>
-            </a:pPr>
-            <a:r>
+              <a:defRPr sz="1600" b="0"/>
+            </a:pPr>
+            <a:r>
+              <a:rPr sz="1350"/>
               <a:t>• KisanSetu AI — an end-to-end smart procurement &amp; queue management platform for Indian APMC Mandis</a:t>
             </a:r>
           </a:p>
           <a:p>
             <a:pPr>
-              <a:defRPr sz="1950" b="0"/>
-            </a:pPr>
-            <a:r>
+              <a:defRPr sz="1600" b="0"/>
+            </a:pPr>
+            <a:r>
+              <a:rPr sz="1350"/>
               <a:t>• Farmers book time-slots digitally from home → receive a unique digital queue token (e.g. A014)</a:t>
             </a:r>
           </a:p>
           <a:p>
             <a:pPr>
-              <a:defRPr sz="1950" b="0"/>
-            </a:pPr>
-            <a:r>
+              <a:defRPr sz="1600" b="0"/>
+            </a:pPr>
+            <a:r>
+              <a:rPr sz="1350"/>
               <a:t>• AI engine scores each slot for congestion (0-100) and recommends the lowest-wait option</a:t>
             </a:r>
           </a:p>
           <a:p>
             <a:pPr>
-              <a:defRPr sz="1950" b="0"/>
-            </a:pPr>
-            <a:r>
+              <a:defRPr sz="1600" b="0"/>
+            </a:pPr>
+            <a:r>
+              <a:rPr sz="1350"/>
               <a:t>• Real-time WebSocket queue board, Desktop Tray Notifier, &amp; phone SMS — zero manual refresh</a:t>
             </a:r>
           </a:p>
           <a:p>
             <a:pPr>
-              <a:defRPr sz="1950" b="0"/>
-            </a:pPr>
-            <a:r>
+              <a:defRPr sz="1600" b="0"/>
+            </a:pPr>
+            <a:r>
+              <a:rPr sz="1350"/>
               <a:t>• Officer digitally grades crop (Grade A / Standard / Moisture %) → instant digital J-Form receipt</a:t>
             </a:r>
           </a:p>
           <a:p>
             <a:pPr>
-              <a:defRPr sz="1950" b="0"/>
-            </a:pPr>
-            <a:r>
+              <a:defRPr sz="1600" b="0"/>
+            </a:pPr>
+            <a:r>
+              <a:rPr sz="1350"/>
               <a:t>• Direct Benefit Transfer (DBT) tracking: PENDING → PROCESSING → COMPLETED with txn ref</a:t>
             </a:r>
           </a:p>
           <a:p>
             <a:pPr>
-              <a:defRPr sz="1950" b="0"/>
-            </a:pPr>
-            <a:r>
+              <a:defRPr sz="1600" b="0"/>
+            </a:pPr>
+            <a:r>
+              <a:rPr sz="1350"/>
               <a:t>• Government admin sees live national KPI dashboard — congestion heatmap, volume, payment rates</a:t>
             </a:r>
           </a:p>
           <a:p>
             <a:pPr>
-              <a:defRPr sz="1000" b="0"/>
-            </a:pPr>
+              <a:defRPr sz="700" b="0"/>
+            </a:pPr>
+            <a:endParaRPr/>
           </a:p>
           <a:p>
             <a:pPr>
-              <a:defRPr sz="1850" b="1"/>
-            </a:pPr>
-            <a:r>
+              <a:defRPr sz="1500" b="1"/>
+            </a:pPr>
+            <a:r>
+              <a:rPr sz="1150" b="1"/>
               <a:t>Innovation: 3-Layer AI Congestion Engine | Desktop Tray App | Multi-Channel SMS (ADB/Cloud) | Zero Paper</a:t>
             </a:r>
           </a:p>
           <a:p>
             <a:pPr>
-              <a:defRPr sz="1800" b="0"/>
-            </a:pPr>
-            <a:r>
+              <a:defRPr sz="1450" b="0"/>
+            </a:pPr>
+            <a:r>
+              <a:rPr sz="1150" b="1"/>
               <a:t>Live App: https://kisansetu-sih.vercel.app</a:t>
             </a:r>
           </a:p>
@@ -6212,7 +6063,7 @@
                 <a16:creationId xmlns:a16="http://schemas.microsoft.com/office/drawing/2014/main" id="{5DBCE864-823D-4A13-9607-5DA1F0ED5FB8}"/>
               </a:ext>
               <a:ext uri="{C183D7F6-B498-43B3-948B-1728B52AA6E4}">
-                <adec:decorative xmlns:adec="http://schemas.microsoft.com/office/drawing/2017/decorative" xmlns="" val="0"/>
+                <adec:decorative xmlns:adec="http://schemas.microsoft.com/office/drawing/2017/decorative" val="0"/>
               </a:ext>
             </a:extLst>
           </p:cNvPr>
@@ -6285,6 +6136,101 @@
           </a:prstGeom>
         </p:spPr>
       </p:pic>
+      <p:pic>
+        <p:nvPicPr>
+          <p:cNvPr id="15363" name="Picture 15362" descr="01_farmer_dashboard.png"/>
+          <p:cNvPicPr>
+            <a:picLocks noChangeAspect="1"/>
+          </p:cNvPicPr>
+          <p:nvPr/>
+        </p:nvPicPr>
+        <p:blipFill>
+          <a:blip r:embed="rId4"/>
+          <a:stretch>
+            <a:fillRect/>
+          </a:stretch>
+        </p:blipFill>
+        <p:spPr>
+          <a:xfrm>
+            <a:off x="6903720" y="1280160"/>
+            <a:ext cx="4709160" cy="2944368"/>
+          </a:xfrm>
+          <a:prstGeom prst="rect">
+            <a:avLst/>
+          </a:prstGeom>
+          <a:ln w="15240">
+            <a:solidFill>
+              <a:srgbClr val="CBD5E1"/>
+            </a:solidFill>
+          </a:ln>
+        </p:spPr>
+      </p:pic>
+      <p:sp>
+        <p:nvSpPr>
+          <p:cNvPr id="15364" name="Rounded Rectangle 15363"/>
+          <p:cNvSpPr/>
+          <p:nvPr/>
+        </p:nvSpPr>
+        <p:spPr>
+          <a:xfrm>
+            <a:off x="6903720" y="4343400"/>
+            <a:ext cx="4709160" cy="1508760"/>
+          </a:xfrm>
+          <a:prstGeom prst="roundRect">
+            <a:avLst/>
+          </a:prstGeom>
+          <a:solidFill>
+            <a:srgbClr val="F8FAFC"/>
+          </a:solidFill>
+          <a:ln w="12700">
+            <a:solidFill>
+              <a:srgbClr val="E2E8F0"/>
+            </a:solidFill>
+          </a:ln>
+        </p:spPr>
+        <p:style>
+          <a:lnRef idx="1">
+            <a:schemeClr val="accent1"/>
+          </a:lnRef>
+          <a:fillRef idx="3">
+            <a:schemeClr val="accent1"/>
+          </a:fillRef>
+          <a:effectRef idx="2">
+            <a:schemeClr val="accent1"/>
+          </a:effectRef>
+          <a:fontRef idx="minor">
+            <a:schemeClr val="lt1"/>
+          </a:fontRef>
+        </p:style>
+        <p:txBody>
+          <a:bodyPr rtlCol="0" anchor="ctr" wrap="square" lIns="164592" rIns="164592" tIns="109728" bIns="91440"/>
+          <a:lstStyle/>
+          <a:p>
+            <a:pPr algn="ctr">
+              <a:defRPr sz="1150" b="1">
+                <a:solidFill>
+                  <a:srgbClr val="15803D"/>
+                </a:solidFill>
+              </a:defRPr>
+            </a:pPr>
+            <a:r>
+              <a:t>🖥️ Live System: Farmer Experience &amp; Digital Token Workflow</a:t>
+            </a:r>
+          </a:p>
+          <a:p>
+            <a:pPr>
+              <a:defRPr sz="1050">
+                <a:solidFill>
+                  <a:srgbClr val="475569"/>
+                </a:solidFill>
+              </a:defRPr>
+            </a:pPr>
+            <a:r>
+              <a:t>Farmers track total DBT payments (₹6.67L+ disbursed), book low-congestion slots with instant digital queue tokens (e.g. A014), and view authenticated J-Forms.</a:t>
+            </a:r>
+          </a:p>
+        </p:txBody>
+      </p:sp>
     </p:spTree>
   </p:cSld>
   <p:clrMapOvr>
@@ -6384,7 +6330,12 @@
             <p:ph type="title"/>
           </p:nvPr>
         </p:nvSpPr>
-        <p:spPr/>
+        <p:spPr>
+          <a:xfrm>
+            <a:off x="609600" y="-47625"/>
+            <a:ext cx="9000000" cy="1143000"/>
+          </a:xfrm>
+        </p:spPr>
         <p:txBody>
           <a:bodyPr/>
           <a:lstStyle/>
@@ -6407,8 +6358,8 @@
         </p:nvSpPr>
         <p:spPr bwMode="auto">
           <a:xfrm>
-            <a:off x="609600" y="2533653"/>
-            <a:ext cx="9385300" cy="1815882"/>
+            <a:off x="612648" y="1188720"/>
+            <a:ext cx="6080760" cy="4846320"/>
           </a:xfrm>
           <a:prstGeom prst="rect">
             <a:avLst/>
@@ -6433,6 +6384,7 @@
               <a:defRPr sz="2600" b="1"/>
             </a:pPr>
             <a:r>
+              <a:rPr sz="2000" b="1"/>
               <a:t>Tech Stack</a:t>
             </a:r>
           </a:p>
@@ -6440,12 +6392,14 @@
             <a:pPr>
               <a:defRPr sz="800" b="0"/>
             </a:pPr>
+            <a:endParaRPr/>
           </a:p>
           <a:p>
             <a:pPr>
               <a:defRPr sz="1850" b="0"/>
             </a:pPr>
             <a:r>
+              <a:rPr sz="1250"/>
               <a:t>Frontend:  Next.js 16 (TypeScript) · Tailwind CSS · App Router · WebSocket client</a:t>
             </a:r>
           </a:p>
@@ -6454,6 +6408,7 @@
               <a:defRPr sz="1850" b="0"/>
             </a:pPr>
             <a:r>
+              <a:rPr sz="1250"/>
               <a:t>Backend:   FastAPI (Python 3.13) · SQLAlchemy 2.0 async · Pydantic v2 · JWT auth</a:t>
             </a:r>
           </a:p>
@@ -6462,6 +6417,7 @@
               <a:defRPr sz="1850" b="0"/>
             </a:pPr>
             <a:r>
+              <a:rPr sz="1250"/>
               <a:t>Database:  SQLite (dev) / PostgreSQL (prod) · Supabase CLI · Zero-downtime store</a:t>
             </a:r>
           </a:p>
@@ -6470,6 +6426,7 @@
               <a:defRPr sz="1850" b="0"/>
             </a:pPr>
             <a:r>
+              <a:rPr sz="1250"/>
               <a:t>Infra:     Docker Compose · GitHub Actions CI/CD · Vercel · System Tray Notifier daemon</a:t>
             </a:r>
           </a:p>
@@ -6478,6 +6435,7 @@
               <a:defRPr sz="1850" b="0"/>
             </a:pPr>
             <a:r>
+              <a:rPr sz="1250"/>
               <a:t>APIs:      REST (12 routers) + 2 WebSocket channels + SMS Gateway (ADB / MSG91)</a:t>
             </a:r>
           </a:p>
@@ -6485,12 +6443,14 @@
             <a:pPr>
               <a:defRPr sz="800" b="0"/>
             </a:pPr>
+            <a:endParaRPr/>
           </a:p>
           <a:p>
             <a:pPr>
               <a:defRPr sz="2200" b="1"/>
             </a:pPr>
             <a:r>
+              <a:rPr sz="2000" b="1"/>
               <a:t>Methodology / Flow</a:t>
             </a:r>
           </a:p>
@@ -6498,12 +6458,14 @@
             <a:pPr>
               <a:defRPr sz="600" b="0"/>
             </a:pPr>
+            <a:endParaRPr/>
           </a:p>
           <a:p>
             <a:pPr>
               <a:defRPr sz="1800" b="0"/>
             </a:pPr>
             <a:r>
+              <a:rPr sz="1250"/>
               <a:t>Farmer → Books Slot via AI Recommendation → Receives Digital Token</a:t>
             </a:r>
           </a:p>
@@ -6512,6 +6474,7 @@
               <a:defRPr sz="1800" b="0"/>
             </a:pPr>
             <a:r>
+              <a:rPr sz="1250"/>
               <a:t>Officer → Calls Token via Queue Desk / Tray Notifier → Digital Grading → J-Form</a:t>
             </a:r>
           </a:p>
@@ -6520,6 +6483,7 @@
               <a:defRPr sz="1800" b="0"/>
             </a:pPr>
             <a:r>
+              <a:rPr sz="1250"/>
               <a:t>System → Instant WebSocket push + Phone SMS alert → DBT Payment PENDING</a:t>
             </a:r>
           </a:p>
@@ -6528,6 +6492,7 @@
               <a:defRPr sz="1800" b="0"/>
             </a:pPr>
             <a:r>
+              <a:rPr sz="1250"/>
               <a:t>Admin → Live Heatmap updates → Monitors Mandi KPIs &amp; Congestion in real-time</a:t>
             </a:r>
           </a:p>
@@ -6535,12 +6500,14 @@
             <a:pPr>
               <a:defRPr sz="600" b="0"/>
             </a:pPr>
+            <a:endParaRPr/>
           </a:p>
           <a:p>
             <a:pPr>
               <a:defRPr sz="1800" b="1"/>
             </a:pPr>
             <a:r>
+              <a:rPr sz="1150" b="1"/>
               <a:t>Prototype: Fully functional — 15 Mandis, 19 crops, 1200+ slots, Tray App · 13 tests passing ✅</a:t>
             </a:r>
           </a:p>
@@ -6625,7 +6592,7 @@
                 <a16:creationId xmlns:a16="http://schemas.microsoft.com/office/drawing/2014/main" id="{5DBCE864-823D-4A13-9607-5DA1F0ED5FB8}"/>
               </a:ext>
               <a:ext uri="{C183D7F6-B498-43B3-948B-1728B52AA6E4}">
-                <adec:decorative xmlns:adec="http://schemas.microsoft.com/office/drawing/2017/decorative" xmlns="" val="0"/>
+                <adec:decorative xmlns:adec="http://schemas.microsoft.com/office/drawing/2017/decorative" val="0"/>
               </a:ext>
             </a:extLst>
           </p:cNvPr>
@@ -6698,6 +6665,101 @@
           </a:prstGeom>
         </p:spPr>
       </p:pic>
+      <p:pic>
+        <p:nvPicPr>
+          <p:cNvPr id="17411" name="Picture 17410" descr="06_officer_procure_tab.png"/>
+          <p:cNvPicPr>
+            <a:picLocks noChangeAspect="1"/>
+          </p:cNvPicPr>
+          <p:nvPr/>
+        </p:nvPicPr>
+        <p:blipFill>
+          <a:blip r:embed="rId4"/>
+          <a:stretch>
+            <a:fillRect/>
+          </a:stretch>
+        </p:blipFill>
+        <p:spPr>
+          <a:xfrm>
+            <a:off x="6903720" y="1280160"/>
+            <a:ext cx="4709160" cy="2944368"/>
+          </a:xfrm>
+          <a:prstGeom prst="rect">
+            <a:avLst/>
+          </a:prstGeom>
+          <a:ln w="15240">
+            <a:solidFill>
+              <a:srgbClr val="CBD5E1"/>
+            </a:solidFill>
+          </a:ln>
+        </p:spPr>
+      </p:pic>
+      <p:sp>
+        <p:nvSpPr>
+          <p:cNvPr id="17412" name="Rounded Rectangle 17411"/>
+          <p:cNvSpPr/>
+          <p:nvPr/>
+        </p:nvSpPr>
+        <p:spPr>
+          <a:xfrm>
+            <a:off x="6903720" y="4343400"/>
+            <a:ext cx="4709160" cy="1508760"/>
+          </a:xfrm>
+          <a:prstGeom prst="roundRect">
+            <a:avLst/>
+          </a:prstGeom>
+          <a:solidFill>
+            <a:srgbClr val="F8FAFC"/>
+          </a:solidFill>
+          <a:ln w="12700">
+            <a:solidFill>
+              <a:srgbClr val="E2E8F0"/>
+            </a:solidFill>
+          </a:ln>
+        </p:spPr>
+        <p:style>
+          <a:lnRef idx="1">
+            <a:schemeClr val="accent1"/>
+          </a:lnRef>
+          <a:fillRef idx="3">
+            <a:schemeClr val="accent1"/>
+          </a:fillRef>
+          <a:effectRef idx="2">
+            <a:schemeClr val="accent1"/>
+          </a:effectRef>
+          <a:fontRef idx="minor">
+            <a:schemeClr val="lt1"/>
+          </a:fontRef>
+        </p:style>
+        <p:txBody>
+          <a:bodyPr rtlCol="0" anchor="ctr" wrap="square" lIns="164592" rIns="164592" tIns="109728" bIns="91440"/>
+          <a:lstStyle/>
+          <a:p>
+            <a:pPr algn="ctr">
+              <a:defRPr sz="1150" b="1">
+                <a:solidFill>
+                  <a:srgbClr val="15803D"/>
+                </a:solidFill>
+              </a:defRPr>
+            </a:pPr>
+            <a:r>
+              <a:t>🖥️ Live System: Procurement Engine &amp; Real-Time Grading</a:t>
+            </a:r>
+          </a:p>
+          <a:p>
+            <a:pPr>
+              <a:defRPr sz="1050">
+                <a:solidFill>
+                  <a:srgbClr val="475569"/>
+                </a:solidFill>
+              </a:defRPr>
+            </a:pPr>
+            <a:r>
+              <a:t>Officer desk automates CACP MSP formulas, moisture &amp; weighbridge deductions, generates signed digital J-Forms, and syncs queue status across mandis.</a:t>
+            </a:r>
+          </a:p>
+        </p:txBody>
+      </p:sp>
     </p:spTree>
   </p:cSld>
   <p:clrMapOvr>
@@ -6812,7 +6874,12 @@
             <p:ph type="title"/>
           </p:nvPr>
         </p:nvSpPr>
-        <p:spPr/>
+        <p:spPr>
+          <a:xfrm>
+            <a:off x="609600" y="-47625"/>
+            <a:ext cx="9000000" cy="1143000"/>
+          </a:xfrm>
+        </p:spPr>
         <p:txBody>
           <a:bodyPr/>
           <a:lstStyle/>
@@ -6835,8 +6902,8 @@
         </p:nvSpPr>
         <p:spPr bwMode="auto">
           <a:xfrm>
-            <a:off x="609600" y="2533653"/>
-            <a:ext cx="9385300" cy="1384995"/>
+            <a:off x="612648" y="1188720"/>
+            <a:ext cx="6080760" cy="4846320"/>
           </a:xfrm>
           <a:prstGeom prst="rect">
             <a:avLst/>
@@ -6873,6 +6940,7 @@
               <a:defRPr sz="2600" b="1"/>
             </a:pPr>
             <a:r>
+              <a:rPr sz="2000" b="1"/>
               <a:t>Feasibility</a:t>
             </a:r>
             <a:endParaRPr kumimoji="0" lang="en-US" sz="2800" b="0" i="0" u="none" strike="noStrike" kern="1200" cap="none" spc="0" normalizeH="0" baseline="0" noProof="0" dirty="0">
@@ -6894,12 +6962,27 @@
             <a:pPr>
               <a:defRPr sz="800" b="0"/>
             </a:pPr>
+            <a:endParaRPr kumimoji="0" lang="en-US" sz="2800" b="0" i="0" u="none" strike="noStrike" kern="1200" cap="none" spc="0" normalizeH="0" baseline="0" noProof="0" dirty="0">
+              <a:ln>
+                <a:noFill/>
+              </a:ln>
+              <a:solidFill>
+                <a:prstClr val="black"/>
+              </a:solidFill>
+              <a:effectLst/>
+              <a:uLnTx/>
+              <a:uFillTx/>
+              <a:latin typeface="Arial" pitchFamily="34" charset="0"/>
+              <a:ea typeface="ＭＳ Ｐゴシック" pitchFamily="1" charset="-128"/>
+              <a:cs typeface="Arial" pitchFamily="34" charset="0"/>
+            </a:endParaRPr>
           </a:p>
           <a:p>
             <a:pPr>
               <a:defRPr sz="1850" b="0"/>
             </a:pPr>
             <a:r>
+              <a:rPr sz="1300"/>
               <a:t>✅  Tech stack is proven, open-source, and free-tier deployable (Vercel + Supabase)</a:t>
             </a:r>
           </a:p>
@@ -6908,6 +6991,7 @@
               <a:defRPr sz="1850" b="0"/>
             </a:pPr>
             <a:r>
+              <a:rPr sz="1300"/>
               <a:t>✅  One-click launcher (start.bat) boots Backend, Frontend, and Tray Notifier concurrently</a:t>
             </a:r>
           </a:p>
@@ -6916,6 +7000,7 @@
               <a:defRPr sz="1850" b="0"/>
             </a:pPr>
             <a:r>
+              <a:rPr sz="1300"/>
               <a:t>✅  GitHub Actions auto-refreshes 14-day slot schedules weekly — zero cloud shutdown</a:t>
             </a:r>
           </a:p>
@@ -6924,6 +7009,7 @@
               <a:defRPr sz="1850" b="0"/>
             </a:pPr>
             <a:r>
+              <a:rPr sz="1300"/>
               <a:t>✅  Scales to 7,000+ APMC Mandis via PostgreSQL read-replicas and distributed caching</a:t>
             </a:r>
           </a:p>
@@ -6931,12 +7017,14 @@
             <a:pPr>
               <a:defRPr sz="800" b="0"/>
             </a:pPr>
+            <a:endParaRPr/>
           </a:p>
           <a:p>
             <a:pPr>
               <a:defRPr sz="2200" b="1"/>
             </a:pPr>
             <a:r>
+              <a:rPr sz="2000" b="1"/>
               <a:t>Challenges &amp; Mitigations</a:t>
             </a:r>
           </a:p>
@@ -6944,12 +7032,14 @@
             <a:pPr>
               <a:defRPr sz="600" b="0"/>
             </a:pPr>
+            <a:endParaRPr/>
           </a:p>
           <a:p>
             <a:pPr>
               <a:defRPr sz="1850" b="0"/>
             </a:pPr>
             <a:r>
+              <a:rPr sz="1300"/>
               <a:t>Challenge: Low smartphone penetration in rural farming communities</a:t>
             </a:r>
           </a:p>
@@ -6958,6 +7048,7 @@
               <a:defRPr sz="1850" b="0"/>
             </a:pPr>
             <a:r>
+              <a:rPr sz="1300"/>
               <a:t>→  Solution: Multi-channel SMS engine (ADB USB bridge + MSG91 DLT gateway) reaches any 2G phone</a:t>
             </a:r>
           </a:p>
@@ -6965,12 +7056,14 @@
             <a:pPr>
               <a:defRPr sz="500" b="0"/>
             </a:pPr>
+            <a:endParaRPr/>
           </a:p>
           <a:p>
             <a:pPr>
               <a:defRPr sz="1850" b="0"/>
             </a:pPr>
             <a:r>
+              <a:rPr sz="1300"/>
               <a:t>Challenge: Internet connectivity / server downtime at remote Mandis</a:t>
             </a:r>
           </a:p>
@@ -6979,6 +7072,7 @@
               <a:defRPr sz="1850" b="0"/>
             </a:pPr>
             <a:r>
+              <a:rPr sz="1300"/>
               <a:t>→  Solution: Resilient dual-layer store (local SQLite / Next.js store) ensures 100% offline uptime</a:t>
             </a:r>
           </a:p>
@@ -6986,12 +7080,14 @@
             <a:pPr>
               <a:defRPr sz="500" b="0"/>
             </a:pPr>
+            <a:endParaRPr/>
           </a:p>
           <a:p>
             <a:pPr>
               <a:defRPr sz="1850" b="0"/>
             </a:pPr>
             <a:r>
+              <a:rPr sz="1300"/>
               <a:t>Challenge: Farmer adoption &amp; digital literacy</a:t>
             </a:r>
           </a:p>
@@ -7000,6 +7096,7 @@
               <a:defRPr sz="1850" b="0"/>
             </a:pPr>
             <a:r>
+              <a:rPr sz="1300"/>
               <a:t>→  Solution: Hindi / Gujarati / regional UI; bilingual audio token calls; Mandi helper desk</a:t>
             </a:r>
           </a:p>
@@ -7167,7 +7264,7 @@
                 <a16:creationId xmlns:a16="http://schemas.microsoft.com/office/drawing/2014/main" id="{5DBCE864-823D-4A13-9607-5DA1F0ED5FB8}"/>
               </a:ext>
               <a:ext uri="{C183D7F6-B498-43B3-948B-1728B52AA6E4}">
-                <adec:decorative xmlns:adec="http://schemas.microsoft.com/office/drawing/2017/decorative" xmlns="" val="0"/>
+                <adec:decorative xmlns:adec="http://schemas.microsoft.com/office/drawing/2017/decorative" val="0"/>
               </a:ext>
             </a:extLst>
           </p:cNvPr>
@@ -7240,6 +7337,101 @@
           </a:prstGeom>
         </p:spPr>
       </p:pic>
+      <p:pic>
+        <p:nvPicPr>
+          <p:cNvPr id="17411" name="Picture 17410" descr="02_smart_slot_recommendations.png"/>
+          <p:cNvPicPr>
+            <a:picLocks noChangeAspect="1"/>
+          </p:cNvPicPr>
+          <p:nvPr/>
+        </p:nvPicPr>
+        <p:blipFill>
+          <a:blip r:embed="rId4"/>
+          <a:stretch>
+            <a:fillRect/>
+          </a:stretch>
+        </p:blipFill>
+        <p:spPr>
+          <a:xfrm>
+            <a:off x="6903720" y="1280160"/>
+            <a:ext cx="4709160" cy="2944368"/>
+          </a:xfrm>
+          <a:prstGeom prst="rect">
+            <a:avLst/>
+          </a:prstGeom>
+          <a:ln w="15240">
+            <a:solidFill>
+              <a:srgbClr val="CBD5E1"/>
+            </a:solidFill>
+          </a:ln>
+        </p:spPr>
+      </p:pic>
+      <p:sp>
+        <p:nvSpPr>
+          <p:cNvPr id="17412" name="Rounded Rectangle 17411"/>
+          <p:cNvSpPr/>
+          <p:nvPr/>
+        </p:nvSpPr>
+        <p:spPr>
+          <a:xfrm>
+            <a:off x="6903720" y="4343400"/>
+            <a:ext cx="4709160" cy="1508760"/>
+          </a:xfrm>
+          <a:prstGeom prst="roundRect">
+            <a:avLst/>
+          </a:prstGeom>
+          <a:solidFill>
+            <a:srgbClr val="F8FAFC"/>
+          </a:solidFill>
+          <a:ln w="12700">
+            <a:solidFill>
+              <a:srgbClr val="E2E8F0"/>
+            </a:solidFill>
+          </a:ln>
+        </p:spPr>
+        <p:style>
+          <a:lnRef idx="1">
+            <a:schemeClr val="accent1"/>
+          </a:lnRef>
+          <a:fillRef idx="3">
+            <a:schemeClr val="accent1"/>
+          </a:fillRef>
+          <a:effectRef idx="2">
+            <a:schemeClr val="accent1"/>
+          </a:effectRef>
+          <a:fontRef idx="minor">
+            <a:schemeClr val="lt1"/>
+          </a:fontRef>
+        </p:style>
+        <p:txBody>
+          <a:bodyPr rtlCol="0" anchor="ctr" wrap="square" lIns="164592" rIns="164592" tIns="109728" bIns="91440"/>
+          <a:lstStyle/>
+          <a:p>
+            <a:pPr algn="ctr">
+              <a:defRPr sz="1150" b="1">
+                <a:solidFill>
+                  <a:srgbClr val="15803D"/>
+                </a:solidFill>
+              </a:defRPr>
+            </a:pPr>
+            <a:r>
+              <a:t>🖥️ Live System: 3-Layer AI Congestion Engine</a:t>
+            </a:r>
+          </a:p>
+          <a:p>
+            <a:pPr>
+              <a:defRPr sz="1050">
+                <a:solidFill>
+                  <a:srgbClr val="475569"/>
+                </a:solidFill>
+              </a:defRPr>
+            </a:pPr>
+            <a:r>
+              <a:t>Real-time demand scoring recommends "⭐ BEST SLOT" with ~0 min wait times, distributing tractor traffic and preventing multi-day harvest bottlenecks.</a:t>
+            </a:r>
+          </a:p>
+        </p:txBody>
+      </p:sp>
     </p:spTree>
     <p:extLst>
       <p:ext uri="{BB962C8B-B14F-4D97-AF65-F5344CB8AC3E}">
@@ -7359,7 +7551,12 @@
             <p:ph type="title"/>
           </p:nvPr>
         </p:nvSpPr>
-        <p:spPr/>
+        <p:spPr>
+          <a:xfrm>
+            <a:off x="609600" y="-47625"/>
+            <a:ext cx="9000000" cy="1143000"/>
+          </a:xfrm>
+        </p:spPr>
         <p:txBody>
           <a:bodyPr/>
           <a:lstStyle/>
@@ -7382,8 +7579,8 @@
         </p:nvSpPr>
         <p:spPr bwMode="auto">
           <a:xfrm>
-            <a:off x="609600" y="2533653"/>
-            <a:ext cx="9385300" cy="1384995"/>
+            <a:off x="612648" y="1188720"/>
+            <a:ext cx="6080760" cy="4846320"/>
           </a:xfrm>
           <a:prstGeom prst="rect">
             <a:avLst/>
@@ -7420,6 +7617,7 @@
               <a:defRPr sz="2600" b="1"/>
             </a:pPr>
             <a:r>
+              <a:rPr sz="2000" b="1"/>
               <a:t>Impact &amp; Benefits</a:t>
             </a:r>
           </a:p>
@@ -7427,12 +7625,14 @@
             <a:pPr>
               <a:defRPr sz="800" b="0"/>
             </a:pPr>
+            <a:endParaRPr/>
           </a:p>
           <a:p>
             <a:pPr>
               <a:defRPr sz="2100" b="1"/>
             </a:pPr>
             <a:r>
+              <a:rPr sz="2000" b="1"/>
               <a:t>Social Impact</a:t>
             </a:r>
           </a:p>
@@ -7441,6 +7641,7 @@
               <a:defRPr sz="1850" b="0"/>
             </a:pPr>
             <a:r>
+              <a:rPr sz="1300"/>
               <a:t>• Average mandi wait time reduced by 23.3% (simulation: 241 min → 185 min)</a:t>
             </a:r>
           </a:p>
@@ -7449,6 +7650,7 @@
               <a:defRPr sz="1850" b="0"/>
             </a:pPr>
             <a:r>
+              <a:rPr sz="1300"/>
               <a:t>• Eliminates 12–48 hour tractor roadblocks at peak Rabi / Kharif harvest seasons</a:t>
             </a:r>
           </a:p>
@@ -7457,6 +7659,7 @@
               <a:defRPr sz="1850" b="0"/>
             </a:pPr>
             <a:r>
+              <a:rPr sz="1300"/>
               <a:t>• Zero post-harvest produce spoilage from multi-day open-air queue bottlenecks</a:t>
             </a:r>
           </a:p>
@@ -7464,12 +7667,14 @@
             <a:pPr>
               <a:defRPr sz="600" b="0"/>
             </a:pPr>
+            <a:endParaRPr/>
           </a:p>
           <a:p>
             <a:pPr>
               <a:defRPr sz="2100" b="1"/>
             </a:pPr>
             <a:r>
+              <a:rPr sz="2000" b="1"/>
               <a:t>Economic Impact</a:t>
             </a:r>
           </a:p>
@@ -7478,6 +7683,7 @@
               <a:defRPr sz="1850" b="0"/>
             </a:pPr>
             <a:r>
+              <a:rPr sz="1300"/>
               <a:t>• Tamper-proof digital J-Form receipts protect farmers against unauthorised deductions</a:t>
             </a:r>
           </a:p>
@@ -7486,6 +7692,7 @@
               <a:defRPr sz="1850" b="0"/>
             </a:pPr>
             <a:r>
+              <a:rPr sz="1300"/>
               <a:t>• Direct Benefit Transfer (DBT) tracking prevents middleman &amp; commission-agent leakage</a:t>
             </a:r>
           </a:p>
@@ -7494,6 +7701,7 @@
               <a:defRPr sz="1850" b="0"/>
             </a:pPr>
             <a:r>
+              <a:rPr sz="1300"/>
               <a:t>• Target: 7,000+ APMC Mandis across India → millions of farmers directly benefited</a:t>
             </a:r>
           </a:p>
@@ -7501,12 +7709,14 @@
             <a:pPr>
               <a:defRPr sz="600" b="0"/>
             </a:pPr>
+            <a:endParaRPr/>
           </a:p>
           <a:p>
             <a:pPr>
               <a:defRPr sz="2100" b="1"/>
             </a:pPr>
             <a:r>
+              <a:rPr sz="2000" b="1"/>
               <a:t>Operational / Government Impact</a:t>
             </a:r>
           </a:p>
@@ -7515,6 +7725,7 @@
               <a:defRPr sz="1850" b="0"/>
             </a:pPr>
             <a:r>
+              <a:rPr sz="1300"/>
               <a:t>• Real-time national KPI dashboard gives DoCA &amp; Ministry officers live actionable data</a:t>
             </a:r>
           </a:p>
@@ -7523,6 +7734,7 @@
               <a:defRPr sz="1850" b="0"/>
             </a:pPr>
             <a:r>
+              <a:rPr sz="1300"/>
               <a:t>• Paperless procurement audit trail — instant verification, weighbridge to bank credit</a:t>
             </a:r>
           </a:p>
@@ -7690,7 +7902,7 @@
                 <a16:creationId xmlns:a16="http://schemas.microsoft.com/office/drawing/2014/main" id="{5DBCE864-823D-4A13-9607-5DA1F0ED5FB8}"/>
               </a:ext>
               <a:ext uri="{C183D7F6-B498-43B3-948B-1728B52AA6E4}">
-                <adec:decorative xmlns:adec="http://schemas.microsoft.com/office/drawing/2017/decorative" xmlns="" val="0"/>
+                <adec:decorative xmlns:adec="http://schemas.microsoft.com/office/drawing/2017/decorative" val="0"/>
               </a:ext>
             </a:extLst>
           </p:cNvPr>
@@ -7763,6 +7975,101 @@
           </a:prstGeom>
         </p:spPr>
       </p:pic>
+      <p:pic>
+        <p:nvPicPr>
+          <p:cNvPr id="17411" name="Picture 17410" descr="07_admin_national_heatmap.png"/>
+          <p:cNvPicPr>
+            <a:picLocks noChangeAspect="1"/>
+          </p:cNvPicPr>
+          <p:nvPr/>
+        </p:nvPicPr>
+        <p:blipFill>
+          <a:blip r:embed="rId4"/>
+          <a:stretch>
+            <a:fillRect/>
+          </a:stretch>
+        </p:blipFill>
+        <p:spPr>
+          <a:xfrm>
+            <a:off x="6903720" y="1280160"/>
+            <a:ext cx="4709160" cy="2944368"/>
+          </a:xfrm>
+          <a:prstGeom prst="rect">
+            <a:avLst/>
+          </a:prstGeom>
+          <a:ln w="15240">
+            <a:solidFill>
+              <a:srgbClr val="CBD5E1"/>
+            </a:solidFill>
+          </a:ln>
+        </p:spPr>
+      </p:pic>
+      <p:sp>
+        <p:nvSpPr>
+          <p:cNvPr id="17412" name="Rounded Rectangle 17411"/>
+          <p:cNvSpPr/>
+          <p:nvPr/>
+        </p:nvSpPr>
+        <p:spPr>
+          <a:xfrm>
+            <a:off x="6903720" y="4343400"/>
+            <a:ext cx="4709160" cy="1508760"/>
+          </a:xfrm>
+          <a:prstGeom prst="roundRect">
+            <a:avLst/>
+          </a:prstGeom>
+          <a:solidFill>
+            <a:srgbClr val="F8FAFC"/>
+          </a:solidFill>
+          <a:ln w="12700">
+            <a:solidFill>
+              <a:srgbClr val="E2E8F0"/>
+            </a:solidFill>
+          </a:ln>
+        </p:spPr>
+        <p:style>
+          <a:lnRef idx="1">
+            <a:schemeClr val="accent1"/>
+          </a:lnRef>
+          <a:fillRef idx="3">
+            <a:schemeClr val="accent1"/>
+          </a:fillRef>
+          <a:effectRef idx="2">
+            <a:schemeClr val="accent1"/>
+          </a:effectRef>
+          <a:fontRef idx="minor">
+            <a:schemeClr val="lt1"/>
+          </a:fontRef>
+        </p:style>
+        <p:txBody>
+          <a:bodyPr rtlCol="0" anchor="ctr" wrap="square" lIns="164592" rIns="164592" tIns="109728" bIns="91440"/>
+          <a:lstStyle/>
+          <a:p>
+            <a:pPr algn="ctr">
+              <a:defRPr sz="1150" b="1">
+                <a:solidFill>
+                  <a:srgbClr val="15803D"/>
+                </a:solidFill>
+              </a:defRPr>
+            </a:pPr>
+            <a:r>
+              <a:t>🖥️ Live System: National Procurement Oversight &amp; Analytics</a:t>
+            </a:r>
+          </a:p>
+          <a:p>
+            <a:pPr>
+              <a:defRPr sz="1050">
+                <a:solidFill>
+                  <a:srgbClr val="475569"/>
+                </a:solidFill>
+              </a:defRPr>
+            </a:pPr>
+            <a:r>
+              <a:t>Live government executive dashboard monitoring 12+ APMC mandis, 2,225+ Qtl procured, 100% DBT disbursement, and real-time regional congestion indices.</a:t>
+            </a:r>
+          </a:p>
+        </p:txBody>
+      </p:sp>
     </p:spTree>
     <p:extLst>
       <p:ext uri="{BB962C8B-B14F-4D97-AF65-F5344CB8AC3E}">
@@ -7882,7 +8189,12 @@
             <p:ph type="title"/>
           </p:nvPr>
         </p:nvSpPr>
-        <p:spPr/>
+        <p:spPr>
+          <a:xfrm>
+            <a:off x="609600" y="-47625"/>
+            <a:ext cx="9000000" cy="1143000"/>
+          </a:xfrm>
+        </p:spPr>
         <p:txBody>
           <a:bodyPr/>
           <a:lstStyle/>
@@ -7905,8 +8217,8 @@
         </p:nvSpPr>
         <p:spPr bwMode="auto">
           <a:xfrm>
-            <a:off x="609600" y="2795263"/>
-            <a:ext cx="9385300" cy="523220"/>
+            <a:off x="612648" y="1188720"/>
+            <a:ext cx="6080760" cy="4846320"/>
           </a:xfrm>
           <a:prstGeom prst="rect">
             <a:avLst/>
@@ -7943,6 +8255,7 @@
               <a:defRPr sz="2600" b="1"/>
             </a:pPr>
             <a:r>
+              <a:rPr sz="2000" b="1"/>
               <a:t>Research &amp; References</a:t>
             </a:r>
             <a:endParaRPr kumimoji="0" lang="en-US" sz="2800" b="0" i="0" u="none" strike="noStrike" kern="1200" cap="none" spc="0" normalizeH="0" baseline="0" noProof="0" dirty="0">
@@ -7964,12 +8277,27 @@
             <a:pPr>
               <a:defRPr sz="800" b="0"/>
             </a:pPr>
+            <a:endParaRPr kumimoji="0" lang="en-US" sz="2800" b="0" i="0" u="none" strike="noStrike" kern="1200" cap="none" spc="0" normalizeH="0" baseline="0" noProof="0" dirty="0">
+              <a:ln>
+                <a:noFill/>
+              </a:ln>
+              <a:solidFill>
+                <a:prstClr val="black"/>
+              </a:solidFill>
+              <a:effectLst/>
+              <a:uLnTx/>
+              <a:uFillTx/>
+              <a:latin typeface="Arial" pitchFamily="34" charset="0"/>
+              <a:ea typeface="ＭＳ Ｐゴシック" pitchFamily="1" charset="-128"/>
+              <a:cs typeface="Arial" pitchFamily="34" charset="0"/>
+            </a:endParaRPr>
           </a:p>
           <a:p>
             <a:pPr>
               <a:defRPr sz="1800" b="0"/>
             </a:pPr>
             <a:r>
+              <a:rPr sz="1300"/>
               <a:t>1. SIH 2026 Problem Statement 26032 — Ministry of Consumer Affairs, Food &amp; Public Distribution</a:t>
             </a:r>
           </a:p>
@@ -7978,6 +8306,7 @@
               <a:defRPr sz="1700" b="0"/>
             </a:pPr>
             <a:r>
+              <a:rPr sz="1300"/>
               <a:t>   https://www.sih.gov.in</a:t>
             </a:r>
           </a:p>
@@ -7985,12 +8314,14 @@
             <a:pPr>
               <a:defRPr sz="600" b="0"/>
             </a:pPr>
+            <a:endParaRPr/>
           </a:p>
           <a:p>
             <a:pPr>
               <a:defRPr sz="1800" b="0"/>
             </a:pPr>
             <a:r>
+              <a:rPr sz="1300"/>
               <a:t>2. APMC Mandi Procurement &amp; MSP Policy — Food Corporation of India (FCI)</a:t>
             </a:r>
           </a:p>
@@ -7999,6 +8330,7 @@
               <a:defRPr sz="1700" b="0"/>
             </a:pPr>
             <a:r>
+              <a:rPr sz="1300"/>
               <a:t>   https://fci.gov.in</a:t>
             </a:r>
           </a:p>
@@ -8006,12 +8338,14 @@
             <a:pPr>
               <a:defRPr sz="600" b="0"/>
             </a:pPr>
+            <a:endParaRPr/>
           </a:p>
           <a:p>
             <a:pPr>
               <a:defRPr sz="1800" b="0"/>
             </a:pPr>
             <a:r>
+              <a:rPr sz="1300"/>
               <a:t>3. Congestion Reduction Simulation — KisanSetu AI Internal Analysis (2026)</a:t>
             </a:r>
           </a:p>
@@ -8020,6 +8354,7 @@
               <a:defRPr sz="1700" b="0"/>
             </a:pPr>
             <a:r>
+              <a:rPr sz="1300"/>
               <a:t>   docs/CONGESTION_REDUCTION_ANALYSIS.md · 23.3% avg wait-time reduction validated</a:t>
             </a:r>
           </a:p>
@@ -8027,12 +8362,14 @@
             <a:pPr>
               <a:defRPr sz="600" b="0"/>
             </a:pPr>
+            <a:endParaRPr/>
           </a:p>
           <a:p>
             <a:pPr>
               <a:defRPr sz="1800" b="0"/>
             </a:pPr>
             <a:r>
+              <a:rPr sz="1300"/>
               <a:t>4. CACP Minimum Support Prices (2024–2026) — Commission for Agricultural Costs &amp; Prices</a:t>
             </a:r>
           </a:p>
@@ -8041,6 +8378,7 @@
               <a:defRPr sz="1800" b="0"/>
             </a:pPr>
             <a:r>
+              <a:rPr sz="1300"/>
               <a:t>5. Tech Stack: FastAPI 0.115 · Next.js 16 · Supabase PostgreSQL · WebSocket RFC 6455</a:t>
             </a:r>
           </a:p>
@@ -8048,12 +8386,14 @@
             <a:pPr>
               <a:defRPr sz="800" b="0"/>
             </a:pPr>
+            <a:endParaRPr/>
           </a:p>
           <a:p>
             <a:pPr>
               <a:defRPr sz="1800" b="1"/>
             </a:pPr>
             <a:r>
+              <a:rPr sz="1150" b="1"/>
               <a:t>Live App:  https://kisansetu-sih.vercel.app</a:t>
             </a:r>
           </a:p>
@@ -8062,6 +8402,7 @@
               <a:defRPr sz="1800" b="1"/>
             </a:pPr>
             <a:r>
+              <a:rPr sz="1150" b="1"/>
               <a:t>GitHub:    https://github.com/YTxFSGAMERz/KisanSetu-AI</a:t>
             </a:r>
           </a:p>
@@ -8229,7 +8570,7 @@
                 <a16:creationId xmlns:a16="http://schemas.microsoft.com/office/drawing/2014/main" id="{5DBCE864-823D-4A13-9607-5DA1F0ED5FB8}"/>
               </a:ext>
               <a:ext uri="{C183D7F6-B498-43B3-948B-1728B52AA6E4}">
-                <adec:decorative xmlns:adec="http://schemas.microsoft.com/office/drawing/2017/decorative" xmlns="" val="0"/>
+                <adec:decorative xmlns:adec="http://schemas.microsoft.com/office/drawing/2017/decorative" val="0"/>
               </a:ext>
             </a:extLst>
           </p:cNvPr>
@@ -8302,290 +8643,57 @@
           </a:prstGeom>
         </p:spPr>
       </p:pic>
-    </p:spTree>
-    <p:extLst>
-      <p:ext uri="{BB962C8B-B14F-4D97-AF65-F5344CB8AC3E}">
-        <p14:creationId xmlns:p14="http://schemas.microsoft.com/office/powerpoint/2010/main" val="3916788613"/>
-      </p:ext>
-    </p:extLst>
-  </p:cSld>
-  <p:clrMapOvr>
-    <a:masterClrMapping/>
-  </p:clrMapOvr>
-</p:sld>
-</file>
-
-<file path=ppt/slides/slide7.xml><?xml version="1.0" encoding="utf-8"?>
-<p:sld xmlns:a="http://schemas.openxmlformats.org/drawingml/2006/main" xmlns:r="http://schemas.openxmlformats.org/officeDocument/2006/relationships" xmlns:p="http://schemas.openxmlformats.org/presentationml/2006/main">
-  <p:cSld>
-    <p:spTree>
-      <p:nvGrpSpPr>
-        <p:cNvPr id="1" name=""/>
-        <p:cNvGrpSpPr/>
-        <p:nvPr/>
-      </p:nvGrpSpPr>
-      <p:grpSpPr>
-        <a:xfrm>
-          <a:off x="0" y="0"/>
-          <a:ext cx="0" cy="0"/>
-          <a:chOff x="0" y="0"/>
-          <a:chExt cx="0" cy="0"/>
-        </a:xfrm>
-      </p:grpSpPr>
-      <p:sp>
-        <p:nvSpPr>
-          <p:cNvPr id="10" name="Rectangle 9">
-            <a:extLst>
-              <a:ext uri="{FF2B5EF4-FFF2-40B4-BE49-F238E27FC236}">
-                <a16:creationId xmlns:a16="http://schemas.microsoft.com/office/drawing/2014/main" id="{AD4F69D3-EEB0-4C4C-9434-B9960FB5854C}"/>
-              </a:ext>
-            </a:extLst>
-          </p:cNvPr>
-          <p:cNvSpPr>
-            <a:spLocks noChangeArrowheads="1"/>
-          </p:cNvSpPr>
+      <p:pic>
+        <p:nvPicPr>
+          <p:cNvPr id="17411" name="Picture 17410" descr="05_dbt_payments.png"/>
+          <p:cNvPicPr>
+            <a:picLocks noChangeAspect="1"/>
+          </p:cNvPicPr>
           <p:nvPr/>
-        </p:nvSpPr>
-        <p:spPr bwMode="auto">
+        </p:nvPicPr>
+        <p:blipFill>
+          <a:blip r:embed="rId4"/>
+          <a:stretch>
+            <a:fillRect/>
+          </a:stretch>
+        </p:blipFill>
+        <p:spPr>
           <a:xfrm>
-            <a:off x="0" y="6354762"/>
-            <a:ext cx="12191999" cy="503238"/>
+            <a:off x="6903720" y="1280160"/>
+            <a:ext cx="4709160" cy="2944368"/>
           </a:xfrm>
           <a:prstGeom prst="rect">
             <a:avLst/>
           </a:prstGeom>
-          <a:solidFill>
-            <a:srgbClr val="0070C0"/>
-          </a:solidFill>
-          <a:ln w="9525">
-            <a:noFill/>
-            <a:miter lim="800000"/>
-            <a:headEnd/>
-            <a:tailEnd/>
+          <a:ln w="15240">
+            <a:solidFill>
+              <a:srgbClr val="CBD5E1"/>
+            </a:solidFill>
           </a:ln>
-          <a:effectLst>
-            <a:outerShdw dist="23000" dir="5400000" rotWithShape="0">
-              <a:srgbClr val="808080">
-                <a:alpha val="34999"/>
-              </a:srgbClr>
-            </a:outerShdw>
-          </a:effectLst>
         </p:spPr>
-        <p:txBody>
-          <a:bodyPr anchor="ctr"/>
-          <a:lstStyle/>
-          <a:p>
-            <a:pPr marL="0" marR="0" lvl="0" indent="0" algn="ctr" defTabSz="457200" rtl="0" eaLnBrk="1" fontAlgn="auto" latinLnBrk="0" hangingPunct="1">
-              <a:lnSpc>
-                <a:spcPct val="100000"/>
-              </a:lnSpc>
-              <a:spcBef>
-                <a:spcPts val="0"/>
-              </a:spcBef>
-              <a:spcAft>
-                <a:spcPts val="0"/>
-              </a:spcAft>
-              <a:buClrTx/>
-              <a:buSzTx/>
-              <a:buFontTx/>
-              <a:buNone/>
-              <a:tabLst/>
-              <a:defRPr/>
-            </a:pPr>
-            <a:endParaRPr kumimoji="0" lang="en-US" sz="1800" b="0" i="0" u="none" strike="noStrike" kern="1200" cap="none" spc="0" normalizeH="0" baseline="0" noProof="0" dirty="0">
-              <a:ln>
-                <a:noFill/>
-              </a:ln>
-              <a:solidFill>
-                <a:srgbClr val="C0504D">
-                  <a:lumMod val="75000"/>
-                </a:srgbClr>
-              </a:solidFill>
-              <a:effectLst/>
-              <a:uLnTx/>
-              <a:uFillTx/>
-              <a:latin typeface="Calibri"/>
-              <a:ea typeface="ＭＳ Ｐゴシック" pitchFamily="1" charset="-128"/>
-              <a:cs typeface="+mn-cs"/>
-            </a:endParaRPr>
-          </a:p>
-        </p:txBody>
-      </p:sp>
-      <p:sp>
-        <p:nvSpPr>
-          <p:cNvPr id="6" name="Slide Number Placeholder 5"/>
-          <p:cNvSpPr>
-            <a:spLocks noGrp="1"/>
-          </p:cNvSpPr>
-          <p:nvPr>
-            <p:ph type="sldNum" sz="quarter" idx="12"/>
-          </p:nvPr>
-        </p:nvSpPr>
-        <p:spPr/>
-        <p:txBody>
-          <a:bodyPr/>
-          <a:lstStyle/>
-          <a:p>
-            <a:pPr marL="0" marR="0" lvl="0" indent="0" algn="r" defTabSz="457200" rtl="0" eaLnBrk="1" fontAlgn="base" latinLnBrk="0" hangingPunct="1">
-              <a:lnSpc>
-                <a:spcPct val="100000"/>
-              </a:lnSpc>
-              <a:spcBef>
-                <a:spcPct val="0"/>
-              </a:spcBef>
-              <a:spcAft>
-                <a:spcPct val="0"/>
-              </a:spcAft>
-              <a:buClrTx/>
-              <a:buSzTx/>
-              <a:buFontTx/>
-              <a:buNone/>
-              <a:tabLst/>
-              <a:defRPr/>
-            </a:pPr>
-            <a:fld id="{677C3CE7-23F7-4828-823C-E0205DF2CF97}" type="slidenum">
-              <a:rPr kumimoji="0" lang="en-US" sz="1200" b="1" i="0" u="none" strike="noStrike" kern="1200" cap="none" spc="0" normalizeH="0" baseline="0" noProof="0">
-                <a:ln>
-                  <a:noFill/>
-                </a:ln>
-                <a:solidFill>
-                  <a:prstClr val="white"/>
-                </a:solidFill>
-                <a:effectLst/>
-                <a:uLnTx/>
-                <a:uFillTx/>
-                <a:latin typeface="TradeGothic" pitchFamily="1" charset="0"/>
-                <a:ea typeface="ＭＳ Ｐゴシック" pitchFamily="1" charset="-128"/>
-                <a:cs typeface="+mn-cs"/>
-              </a:rPr>
-              <a:pPr marL="0" marR="0" lvl="0" indent="0" algn="r" defTabSz="457200" rtl="0" eaLnBrk="1" fontAlgn="base" latinLnBrk="0" hangingPunct="1">
-                <a:lnSpc>
-                  <a:spcPct val="100000"/>
-                </a:lnSpc>
-                <a:spcBef>
-                  <a:spcPct val="0"/>
-                </a:spcBef>
-                <a:spcAft>
-                  <a:spcPct val="0"/>
-                </a:spcAft>
-                <a:buClrTx/>
-                <a:buSzTx/>
-                <a:buFontTx/>
-                <a:buNone/>
-                <a:tabLst/>
-                <a:defRPr/>
-              </a:pPr>
-              <a:t>7</a:t>
-            </a:fld>
-            <a:endParaRPr kumimoji="0" lang="en-US" sz="1200" b="1" i="0" u="none" strike="noStrike" kern="1200" cap="none" spc="0" normalizeH="0" baseline="0" noProof="0" dirty="0">
-              <a:ln>
-                <a:noFill/>
-              </a:ln>
-              <a:solidFill>
-                <a:prstClr val="white"/>
-              </a:solidFill>
-              <a:effectLst/>
-              <a:uLnTx/>
-              <a:uFillTx/>
-              <a:latin typeface="TradeGothic" pitchFamily="1" charset="0"/>
-              <a:ea typeface="ＭＳ Ｐゴシック" pitchFamily="1" charset="-128"/>
-              <a:cs typeface="+mn-cs"/>
-            </a:endParaRPr>
-          </a:p>
-        </p:txBody>
-      </p:sp>
-      <p:sp>
-        <p:nvSpPr>
-          <p:cNvPr id="7" name="Footer Placeholder 6"/>
-          <p:cNvSpPr>
-            <a:spLocks noGrp="1"/>
-          </p:cNvSpPr>
-          <p:nvPr>
-            <p:ph type="ftr" sz="quarter" idx="11"/>
-          </p:nvPr>
+      </p:pic>
+      <p:sp>
+        <p:nvSpPr>
+          <p:cNvPr id="17412" name="Rounded Rectangle 17411"/>
+          <p:cNvSpPr/>
+          <p:nvPr/>
         </p:nvSpPr>
         <p:spPr>
           <a:xfrm>
-            <a:off x="4648200" y="6356353"/>
-            <a:ext cx="3204000" cy="365125"/>
+            <a:off x="6903720" y="4343400"/>
+            <a:ext cx="4709160" cy="1508760"/>
           </a:xfrm>
-        </p:spPr>
-        <p:txBody>
-          <a:bodyPr/>
-          <a:lstStyle/>
-          <a:p>
-            <a:pPr marL="0" marR="0" lvl="0" indent="0" algn="ctr" defTabSz="457200" rtl="0" eaLnBrk="1" fontAlgn="auto" latinLnBrk="0" hangingPunct="1">
-              <a:lnSpc>
-                <a:spcPct val="100000"/>
-              </a:lnSpc>
-              <a:spcBef>
-                <a:spcPts val="0"/>
-              </a:spcBef>
-              <a:spcAft>
-                <a:spcPts val="0"/>
-              </a:spcAft>
-              <a:buClrTx/>
-              <a:buSzTx/>
-              <a:buFontTx/>
-              <a:buNone/>
-              <a:tabLst/>
-              <a:defRPr/>
-            </a:pPr>
-            <a:r>
-              <a:rPr kumimoji="0" lang="en-US" sz="1200" b="0" i="0" u="none" strike="noStrike" kern="1200" cap="none" spc="0" normalizeH="0" baseline="0" noProof="0">
-                <a:ln>
-                  <a:noFill/>
-                </a:ln>
-                <a:solidFill>
-                  <a:prstClr val="white"/>
-                </a:solidFill>
-                <a:effectLst/>
-                <a:uLnTx/>
-                <a:uFillTx/>
-                <a:latin typeface="TradeGothic"/>
-                <a:ea typeface="+mn-ea"/>
-                <a:cs typeface="+mn-cs"/>
-              </a:rPr>
-              <a:t>@SIH Idea submission- Template</a:t>
-            </a:r>
-            <a:endParaRPr kumimoji="0" lang="en-US" sz="1200" b="0" i="0" u="none" strike="noStrike" kern="1200" cap="none" spc="0" normalizeH="0" baseline="0" noProof="0" dirty="0">
-              <a:ln>
-                <a:noFill/>
-              </a:ln>
-              <a:solidFill>
-                <a:prstClr val="white"/>
-              </a:solidFill>
-              <a:effectLst/>
-              <a:uLnTx/>
-              <a:uFillTx/>
-              <a:latin typeface="TradeGothic"/>
-              <a:ea typeface="+mn-ea"/>
-              <a:cs typeface="+mn-cs"/>
-            </a:endParaRPr>
-          </a:p>
-        </p:txBody>
-      </p:sp>
-      <p:sp>
-        <p:nvSpPr>
-          <p:cNvPr id="3" name="Round Diagonal Corner Rectangle 2"/>
-          <p:cNvSpPr/>
-          <p:nvPr/>
-        </p:nvSpPr>
-        <p:spPr>
-          <a:xfrm>
-            <a:off x="0" y="1791032"/>
-            <a:ext cx="12192000" cy="4319200"/>
-          </a:xfrm>
-          <a:prstGeom prst="round2DiagRect">
+          <a:prstGeom prst="roundRect">
             <a:avLst/>
           </a:prstGeom>
           <a:solidFill>
-            <a:schemeClr val="accent1">
-              <a:lumMod val="20000"/>
-              <a:lumOff val="80000"/>
-            </a:schemeClr>
+            <a:srgbClr val="F8FAFC"/>
           </a:solidFill>
-          <a:ln w="38100"/>
+          <a:ln w="12700">
+            <a:solidFill>
+              <a:srgbClr val="E2E8F0"/>
+            </a:solidFill>
+          </a:ln>
         </p:spPr>
         <p:style>
           <a:lnRef idx="1">
@@ -8602,563 +8710,38 @@
           </a:fontRef>
         </p:style>
         <p:txBody>
-          <a:bodyPr rtlCol="0" anchor="ctr"/>
+          <a:bodyPr rtlCol="0" anchor="ctr" wrap="square" lIns="164592" rIns="164592" tIns="109728" bIns="91440"/>
           <a:lstStyle/>
           <a:p>
-            <a:pPr algn="ctr"/>
-            <a:endParaRPr lang="en-IN"/>
-          </a:p>
-        </p:txBody>
-      </p:sp>
-      <p:sp>
-        <p:nvSpPr>
-          <p:cNvPr id="12" name="Google Shape;100;p3"/>
-          <p:cNvSpPr txBox="1"/>
-          <p:nvPr/>
-        </p:nvSpPr>
-        <p:spPr>
-          <a:xfrm>
-            <a:off x="367832" y="1915454"/>
-            <a:ext cx="11764736" cy="4070356"/>
-          </a:xfrm>
-          <a:prstGeom prst="rect">
-            <a:avLst/>
-          </a:prstGeom>
-          <a:noFill/>
-          <a:ln>
-            <a:noFill/>
-          </a:ln>
-        </p:spPr>
-        <p:txBody>
-          <a:bodyPr spcFirstLastPara="1" wrap="square" lIns="91425" tIns="45700" rIns="91425" bIns="45700" anchor="t" anchorCtr="0">
-            <a:noAutofit/>
-          </a:bodyPr>
-          <a:lstStyle/>
-          <a:p>
-            <a:pPr marL="514350" marR="0" lvl="0" indent="-514350" algn="just" rtl="0">
-              <a:lnSpc>
-                <a:spcPct val="90000"/>
-              </a:lnSpc>
-              <a:spcBef>
-                <a:spcPts val="0"/>
-              </a:spcBef>
-              <a:spcAft>
-                <a:spcPts val="0"/>
-              </a:spcAft>
-              <a:buClr>
-                <a:schemeClr val="dk1"/>
-              </a:buClr>
-              <a:buSzPct val="100000"/>
-              <a:buFont typeface="Calibri"/>
-              <a:buAutoNum type="arabicPeriod"/>
-            </a:pPr>
-            <a:r>
-              <a:rPr lang="en-US" b="1" i="0" u="none" strike="noStrike" cap="none" dirty="0">
+            <a:pPr algn="ctr">
+              <a:defRPr sz="1150" b="1">
                 <a:solidFill>
-                  <a:schemeClr val="dk1"/>
+                  <a:srgbClr val="15803D"/>
                 </a:solidFill>
-                <a:latin typeface="Arial" panose="020B0604020202020204" pitchFamily="34" charset="0"/>
-                <a:ea typeface="Calibri"/>
-                <a:cs typeface="Arial" panose="020B0604020202020204" pitchFamily="34" charset="0"/>
-                <a:sym typeface="Calibri"/>
-              </a:rPr>
-              <a:t>Kindly keep the maximum slides limit up to six </a:t>
-            </a:r>
-            <a:r>
-              <a:rPr lang="en-US" b="1" i="0" u="none" strike="noStrike" cap="none" dirty="0">
+              </a:defRPr>
+            </a:pPr>
+            <a:r>
+              <a:t>🖥️ Live System: PFMS Direct Benefit Transfer (DBT) Ledger</a:t>
+            </a:r>
+          </a:p>
+          <a:p>
+            <a:pPr>
+              <a:defRPr sz="1050">
                 <a:solidFill>
-                  <a:srgbClr val="C00000"/>
+                  <a:srgbClr val="475569"/>
                 </a:solidFill>
-                <a:latin typeface="Arial" panose="020B0604020202020204" pitchFamily="34" charset="0"/>
-                <a:ea typeface="Calibri"/>
-                <a:cs typeface="Arial" panose="020B0604020202020204" pitchFamily="34" charset="0"/>
-                <a:sym typeface="Calibri"/>
-              </a:rPr>
-              <a:t>(6). </a:t>
-            </a:r>
-            <a:r>
-              <a:rPr lang="en-US" b="1" i="0" u="none" strike="noStrike" cap="none" dirty="0">
-                <a:solidFill>
-                  <a:schemeClr val="dk1"/>
-                </a:solidFill>
-                <a:latin typeface="Arial" panose="020B0604020202020204" pitchFamily="34" charset="0"/>
-                <a:ea typeface="Calibri"/>
-                <a:cs typeface="Arial" panose="020B0604020202020204" pitchFamily="34" charset="0"/>
-                <a:sym typeface="Calibri"/>
-              </a:rPr>
-              <a:t>( Including the </a:t>
-            </a:r>
-            <a:r>
-              <a:rPr lang="en-US" b="1" i="0" u="none" strike="noStrike" cap="none">
-                <a:solidFill>
-                  <a:schemeClr val="dk1"/>
-                </a:solidFill>
-                <a:latin typeface="Arial" panose="020B0604020202020204" pitchFamily="34" charset="0"/>
-                <a:ea typeface="Calibri"/>
-                <a:cs typeface="Arial" panose="020B0604020202020204" pitchFamily="34" charset="0"/>
-                <a:sym typeface="Calibri"/>
-              </a:rPr>
-              <a:t>title slide) </a:t>
-            </a:r>
-            <a:endParaRPr b="1" dirty="0">
-              <a:latin typeface="Arial" panose="020B0604020202020204" pitchFamily="34" charset="0"/>
-              <a:cs typeface="Arial" panose="020B0604020202020204" pitchFamily="34" charset="0"/>
-            </a:endParaRPr>
-          </a:p>
-          <a:p>
-            <a:pPr marL="514350" marR="0" lvl="0" indent="-514350" algn="just" rtl="0">
-              <a:lnSpc>
-                <a:spcPct val="90000"/>
-              </a:lnSpc>
-              <a:spcBef>
-                <a:spcPts val="1000"/>
-              </a:spcBef>
-              <a:spcAft>
-                <a:spcPts val="0"/>
-              </a:spcAft>
-              <a:buClr>
-                <a:schemeClr val="dk1"/>
-              </a:buClr>
-              <a:buSzPct val="100000"/>
-              <a:buFont typeface="Calibri"/>
-              <a:buAutoNum type="arabicPeriod"/>
-            </a:pPr>
-            <a:r>
-              <a:rPr lang="en-US" b="1" i="0" u="none" strike="noStrike" cap="none" dirty="0">
-                <a:solidFill>
-                  <a:schemeClr val="dk1"/>
-                </a:solidFill>
-                <a:latin typeface="Arial" panose="020B0604020202020204" pitchFamily="34" charset="0"/>
-                <a:ea typeface="Calibri"/>
-                <a:cs typeface="Arial" panose="020B0604020202020204" pitchFamily="34" charset="0"/>
-                <a:sym typeface="Calibri"/>
-              </a:rPr>
-              <a:t>Try to avoid paragraphs and post your idea in points /diagrams / Infographics /pictures </a:t>
-            </a:r>
-            <a:endParaRPr b="1" dirty="0">
-              <a:latin typeface="Arial" panose="020B0604020202020204" pitchFamily="34" charset="0"/>
-              <a:cs typeface="Arial" panose="020B0604020202020204" pitchFamily="34" charset="0"/>
-            </a:endParaRPr>
-          </a:p>
-          <a:p>
-            <a:pPr marL="514350" marR="0" lvl="0" indent="-514350" algn="just" rtl="0">
-              <a:lnSpc>
-                <a:spcPct val="90000"/>
-              </a:lnSpc>
-              <a:spcBef>
-                <a:spcPts val="1000"/>
-              </a:spcBef>
-              <a:spcAft>
-                <a:spcPts val="0"/>
-              </a:spcAft>
-              <a:buClr>
-                <a:schemeClr val="dk1"/>
-              </a:buClr>
-              <a:buSzPct val="100000"/>
-              <a:buFont typeface="Calibri"/>
-              <a:buAutoNum type="arabicPeriod"/>
-            </a:pPr>
-            <a:r>
-              <a:rPr lang="en-US" b="1" i="0" u="none" strike="noStrike" cap="none" dirty="0">
-                <a:solidFill>
-                  <a:schemeClr val="dk1"/>
-                </a:solidFill>
-                <a:latin typeface="Arial" panose="020B0604020202020204" pitchFamily="34" charset="0"/>
-                <a:ea typeface="Calibri"/>
-                <a:cs typeface="Arial" panose="020B0604020202020204" pitchFamily="34" charset="0"/>
-                <a:sym typeface="Calibri"/>
-              </a:rPr>
-              <a:t>Keep your explanation precise and easy to understand</a:t>
-            </a:r>
-            <a:endParaRPr b="1" dirty="0">
-              <a:latin typeface="Arial" panose="020B0604020202020204" pitchFamily="34" charset="0"/>
-              <a:cs typeface="Arial" panose="020B0604020202020204" pitchFamily="34" charset="0"/>
-            </a:endParaRPr>
-          </a:p>
-          <a:p>
-            <a:pPr marL="514350" marR="0" lvl="0" indent="-514350" algn="just" rtl="0">
-              <a:lnSpc>
-                <a:spcPct val="90000"/>
-              </a:lnSpc>
-              <a:spcBef>
-                <a:spcPts val="1000"/>
-              </a:spcBef>
-              <a:spcAft>
-                <a:spcPts val="0"/>
-              </a:spcAft>
-              <a:buClr>
-                <a:schemeClr val="dk1"/>
-              </a:buClr>
-              <a:buSzPct val="100000"/>
-              <a:buFont typeface="Calibri"/>
-              <a:buAutoNum type="arabicPeriod"/>
-            </a:pPr>
-            <a:r>
-              <a:rPr lang="en-US" b="1" i="0" u="none" strike="noStrike" cap="none" dirty="0">
-                <a:solidFill>
-                  <a:schemeClr val="dk1"/>
-                </a:solidFill>
-                <a:latin typeface="Arial" panose="020B0604020202020204" pitchFamily="34" charset="0"/>
-                <a:ea typeface="Calibri"/>
-                <a:cs typeface="Arial" panose="020B0604020202020204" pitchFamily="34" charset="0"/>
-                <a:sym typeface="Calibri"/>
-              </a:rPr>
-              <a:t>Idea should be unique and novel. </a:t>
-            </a:r>
-            <a:endParaRPr b="1" dirty="0">
-              <a:latin typeface="Arial" panose="020B0604020202020204" pitchFamily="34" charset="0"/>
-              <a:cs typeface="Arial" panose="020B0604020202020204" pitchFamily="34" charset="0"/>
-            </a:endParaRPr>
-          </a:p>
-          <a:p>
-            <a:pPr marL="514350" marR="0" lvl="0" indent="-514350" algn="just" rtl="0">
-              <a:lnSpc>
-                <a:spcPct val="90000"/>
-              </a:lnSpc>
-              <a:spcBef>
-                <a:spcPts val="1000"/>
-              </a:spcBef>
-              <a:spcAft>
-                <a:spcPts val="0"/>
-              </a:spcAft>
-              <a:buClr>
-                <a:schemeClr val="dk1"/>
-              </a:buClr>
-              <a:buSzPct val="100000"/>
-              <a:buFont typeface="Calibri"/>
-              <a:buAutoNum type="arabicPeriod"/>
-            </a:pPr>
-            <a:r>
-              <a:rPr lang="en-US" b="1" i="0" u="none" strike="noStrike" cap="none" dirty="0">
-                <a:solidFill>
-                  <a:schemeClr val="dk1"/>
-                </a:solidFill>
-                <a:latin typeface="Arial" panose="020B0604020202020204" pitchFamily="34" charset="0"/>
-                <a:ea typeface="Calibri"/>
-                <a:cs typeface="Arial" panose="020B0604020202020204" pitchFamily="34" charset="0"/>
-                <a:sym typeface="Calibri"/>
-              </a:rPr>
-              <a:t>You can only use provided </a:t>
-            </a:r>
-            <a:r>
-              <a:rPr lang="en-US" b="1" dirty="0">
-                <a:solidFill>
-                  <a:schemeClr val="dk1"/>
-                </a:solidFill>
-                <a:latin typeface="Arial" panose="020B0604020202020204" pitchFamily="34" charset="0"/>
-                <a:ea typeface="Calibri"/>
-                <a:cs typeface="Arial" panose="020B0604020202020204" pitchFamily="34" charset="0"/>
-                <a:sym typeface="Calibri"/>
-              </a:rPr>
-              <a:t>template</a:t>
-            </a:r>
-            <a:r>
-              <a:rPr lang="en-US" b="1" i="0" u="none" strike="noStrike" cap="none" dirty="0">
-                <a:solidFill>
-                  <a:schemeClr val="dk1"/>
-                </a:solidFill>
-                <a:latin typeface="Arial" panose="020B0604020202020204" pitchFamily="34" charset="0"/>
-                <a:ea typeface="Calibri"/>
-                <a:cs typeface="Arial" panose="020B0604020202020204" pitchFamily="34" charset="0"/>
-                <a:sym typeface="Calibri"/>
-              </a:rPr>
-              <a:t> for making the </a:t>
-            </a:r>
-            <a:r>
-              <a:rPr lang="en-US" b="1" dirty="0">
-                <a:solidFill>
-                  <a:schemeClr val="dk1"/>
-                </a:solidFill>
-                <a:latin typeface="Arial" panose="020B0604020202020204" pitchFamily="34" charset="0"/>
-                <a:ea typeface="Calibri"/>
-                <a:cs typeface="Arial" panose="020B0604020202020204" pitchFamily="34" charset="0"/>
-                <a:sym typeface="Calibri"/>
-              </a:rPr>
-              <a:t>PPT</a:t>
-            </a:r>
-            <a:r>
-              <a:rPr lang="en-US" b="1" i="0" u="none" strike="noStrike" cap="none" dirty="0">
-                <a:solidFill>
-                  <a:schemeClr val="dk1"/>
-                </a:solidFill>
-                <a:latin typeface="Arial" panose="020B0604020202020204" pitchFamily="34" charset="0"/>
-                <a:ea typeface="Calibri"/>
-                <a:cs typeface="Arial" panose="020B0604020202020204" pitchFamily="34" charset="0"/>
-                <a:sym typeface="Calibri"/>
-              </a:rPr>
-              <a:t> without changing the idea details pointers (mentioned in previous slides).</a:t>
-            </a:r>
-            <a:endParaRPr b="1" i="0" u="none" strike="noStrike" cap="none" dirty="0">
-              <a:solidFill>
-                <a:schemeClr val="dk1"/>
-              </a:solidFill>
-              <a:latin typeface="Arial" panose="020B0604020202020204" pitchFamily="34" charset="0"/>
-              <a:ea typeface="Calibri"/>
-              <a:cs typeface="Arial" panose="020B0604020202020204" pitchFamily="34" charset="0"/>
-              <a:sym typeface="Calibri"/>
-            </a:endParaRPr>
-          </a:p>
-          <a:p>
-            <a:pPr marL="514350" marR="0" lvl="0" indent="-514350" algn="just" rtl="0">
-              <a:lnSpc>
-                <a:spcPct val="90000"/>
-              </a:lnSpc>
-              <a:spcBef>
-                <a:spcPts val="1000"/>
-              </a:spcBef>
-              <a:spcAft>
-                <a:spcPts val="0"/>
-              </a:spcAft>
-              <a:buClr>
-                <a:schemeClr val="dk1"/>
-              </a:buClr>
-              <a:buSzPct val="100000"/>
-              <a:buFont typeface="Calibri"/>
-              <a:buAutoNum type="arabicPeriod"/>
-            </a:pPr>
-            <a:r>
-              <a:rPr lang="en-US" b="1" i="0" u="none" strike="noStrike" cap="none" dirty="0">
-                <a:solidFill>
-                  <a:schemeClr val="dk1"/>
-                </a:solidFill>
-                <a:latin typeface="Arial" panose="020B0604020202020204" pitchFamily="34" charset="0"/>
-                <a:ea typeface="Calibri"/>
-                <a:cs typeface="Arial" panose="020B0604020202020204" pitchFamily="34" charset="0"/>
-                <a:sym typeface="Calibri"/>
-              </a:rPr>
-              <a:t>You need to save the file in PDF and upload the same on portal. No PPT, Word Doc or any other format will be supported.</a:t>
-            </a:r>
-            <a:endParaRPr b="1" dirty="0">
-              <a:latin typeface="Arial" panose="020B0604020202020204" pitchFamily="34" charset="0"/>
-              <a:cs typeface="Arial" panose="020B0604020202020204" pitchFamily="34" charset="0"/>
-            </a:endParaRPr>
-          </a:p>
-          <a:p>
-            <a:pPr marL="514350" marR="0" lvl="0" indent="-349885" algn="just" rtl="0">
-              <a:lnSpc>
-                <a:spcPct val="90000"/>
-              </a:lnSpc>
-              <a:spcBef>
-                <a:spcPts val="1000"/>
-              </a:spcBef>
-              <a:spcAft>
-                <a:spcPts val="0"/>
-              </a:spcAft>
-              <a:buClr>
-                <a:schemeClr val="dk1"/>
-              </a:buClr>
-              <a:buSzPct val="100000"/>
-              <a:buFont typeface="Calibri"/>
-              <a:buNone/>
-            </a:pPr>
-            <a:endParaRPr b="1" i="0" u="none" strike="noStrike" cap="none" dirty="0">
-              <a:solidFill>
-                <a:schemeClr val="dk1"/>
-              </a:solidFill>
-              <a:latin typeface="Arial" panose="020B0604020202020204" pitchFamily="34" charset="0"/>
-              <a:ea typeface="Calibri"/>
-              <a:cs typeface="Arial" panose="020B0604020202020204" pitchFamily="34" charset="0"/>
-              <a:sym typeface="Calibri"/>
-            </a:endParaRPr>
-          </a:p>
-          <a:p>
-            <a:pPr marL="0" marR="0" lvl="0" indent="0" algn="just" rtl="0">
-              <a:lnSpc>
-                <a:spcPct val="90000"/>
-              </a:lnSpc>
-              <a:spcBef>
-                <a:spcPts val="1000"/>
-              </a:spcBef>
-              <a:spcAft>
-                <a:spcPts val="0"/>
-              </a:spcAft>
-              <a:buClr>
-                <a:schemeClr val="dk1"/>
-              </a:buClr>
-              <a:buSzPct val="100000"/>
-              <a:buFont typeface="Arial"/>
-              <a:buNone/>
-            </a:pPr>
-            <a:r>
-              <a:rPr lang="en-US" b="1" i="0" u="none" strike="noStrike" cap="none" dirty="0">
-                <a:solidFill>
-                  <a:srgbClr val="C00000"/>
-                </a:solidFill>
-                <a:latin typeface="Arial" panose="020B0604020202020204" pitchFamily="34" charset="0"/>
-                <a:ea typeface="Calibri"/>
-                <a:cs typeface="Arial" panose="020B0604020202020204" pitchFamily="34" charset="0"/>
-                <a:sym typeface="Calibri"/>
-              </a:rPr>
-              <a:t>Note - You can delete this slide (Important Pointers) when you upload the details of your idea on SIH portal.</a:t>
-            </a:r>
-            <a:endParaRPr b="1" dirty="0">
-              <a:solidFill>
-                <a:srgbClr val="C00000"/>
-              </a:solidFill>
-              <a:latin typeface="Arial" panose="020B0604020202020204" pitchFamily="34" charset="0"/>
-              <a:cs typeface="Arial" panose="020B0604020202020204" pitchFamily="34" charset="0"/>
-            </a:endParaRPr>
-          </a:p>
-          <a:p>
-            <a:pPr marL="914400" marR="0" lvl="1" indent="-316230" algn="just" rtl="0">
-              <a:lnSpc>
-                <a:spcPct val="90000"/>
-              </a:lnSpc>
-              <a:spcBef>
-                <a:spcPts val="500"/>
-              </a:spcBef>
-              <a:spcAft>
-                <a:spcPts val="0"/>
-              </a:spcAft>
-              <a:buClr>
-                <a:schemeClr val="dk1"/>
-              </a:buClr>
-              <a:buSzPct val="100000"/>
-              <a:buFont typeface="Calibri"/>
-              <a:buNone/>
-            </a:pPr>
-            <a:endParaRPr sz="2000" b="1" i="0" u="none" strike="noStrike" cap="none" dirty="0">
-              <a:solidFill>
-                <a:schemeClr val="dk1"/>
-              </a:solidFill>
-              <a:latin typeface="Arial" panose="020B0604020202020204" pitchFamily="34" charset="0"/>
-              <a:ea typeface="Calibri"/>
-              <a:cs typeface="Arial" panose="020B0604020202020204" pitchFamily="34" charset="0"/>
-              <a:sym typeface="Calibri"/>
-            </a:endParaRPr>
-          </a:p>
-        </p:txBody>
-      </p:sp>
-      <p:sp>
-        <p:nvSpPr>
-          <p:cNvPr id="4" name="TextBox 3"/>
-          <p:cNvSpPr txBox="1"/>
-          <p:nvPr/>
-        </p:nvSpPr>
-        <p:spPr>
-          <a:xfrm>
-            <a:off x="1393371" y="107066"/>
-            <a:ext cx="8410540" cy="646331"/>
-          </a:xfrm>
-          <a:prstGeom prst="rect">
-            <a:avLst/>
-          </a:prstGeom>
-          <a:noFill/>
-        </p:spPr>
-        <p:txBody>
-          <a:bodyPr wrap="square" rtlCol="0">
-            <a:spAutoFit/>
-          </a:bodyPr>
-          <a:lstStyle/>
-          <a:p>
-            <a:pPr algn="ctr"/>
-            <a:r>
-              <a:rPr lang="en-US" sz="3600" b="1" dirty="0">
-                <a:latin typeface="Times New Roman" panose="02020603050405020304" pitchFamily="18" charset="0"/>
-                <a:cs typeface="Times New Roman" panose="02020603050405020304" pitchFamily="18" charset="0"/>
-              </a:rPr>
-              <a:t>IMPORTANT INSTRUCTIONS</a:t>
-            </a:r>
-            <a:endParaRPr lang="en-IN" sz="3600" b="1" dirty="0">
-              <a:latin typeface="Times New Roman" panose="02020603050405020304" pitchFamily="18" charset="0"/>
-              <a:cs typeface="Times New Roman" panose="02020603050405020304" pitchFamily="18" charset="0"/>
-            </a:endParaRPr>
-          </a:p>
-        </p:txBody>
-      </p:sp>
-      <p:sp>
-        <p:nvSpPr>
-          <p:cNvPr id="5" name="TextBox 4"/>
-          <p:cNvSpPr txBox="1"/>
-          <p:nvPr/>
-        </p:nvSpPr>
-        <p:spPr>
-          <a:xfrm>
-            <a:off x="602343" y="1181900"/>
-            <a:ext cx="9557657" cy="341632"/>
-          </a:xfrm>
-          <a:prstGeom prst="rect">
-            <a:avLst/>
-          </a:prstGeom>
-          <a:noFill/>
-        </p:spPr>
-        <p:txBody>
-          <a:bodyPr wrap="square" rtlCol="0">
-            <a:spAutoFit/>
-          </a:bodyPr>
-          <a:lstStyle/>
-          <a:p>
-            <a:pPr algn="just">
-              <a:lnSpc>
-                <a:spcPct val="90000"/>
-              </a:lnSpc>
-              <a:spcBef>
-                <a:spcPts val="1000"/>
-              </a:spcBef>
-              <a:spcAft>
-                <a:spcPts val="0"/>
-              </a:spcAft>
-              <a:buClr>
-                <a:schemeClr val="dk1"/>
-              </a:buClr>
-              <a:buSzPct val="100000"/>
-            </a:pPr>
-            <a:r>
-              <a:rPr lang="en-US" b="1" dirty="0">
-                <a:solidFill>
-                  <a:schemeClr val="dk1"/>
-                </a:solidFill>
-                <a:latin typeface="Arial" panose="020B0604020202020204" pitchFamily="34" charset="0"/>
-                <a:ea typeface="Calibri"/>
-                <a:cs typeface="Arial" panose="020B0604020202020204" pitchFamily="34" charset="0"/>
-              </a:rPr>
-              <a:t>Please ensure below pointers are met while submitting the Idea PPT:</a:t>
-            </a:r>
-            <a:endParaRPr lang="en-IN" b="1" dirty="0">
-              <a:solidFill>
-                <a:schemeClr val="dk1"/>
-              </a:solidFill>
-              <a:latin typeface="Arial" panose="020B0604020202020204" pitchFamily="34" charset="0"/>
-              <a:ea typeface="Calibri"/>
-              <a:cs typeface="Arial" panose="020B0604020202020204" pitchFamily="34" charset="0"/>
-            </a:endParaRPr>
-          </a:p>
-        </p:txBody>
-      </p:sp>
-      <p:pic>
-        <p:nvPicPr>
-          <p:cNvPr id="13" name="Picture 12"/>
-          <p:cNvPicPr>
-            <a:picLocks noChangeAspect="1"/>
-          </p:cNvPicPr>
-          <p:nvPr/>
-        </p:nvPicPr>
-        <p:blipFill>
-          <a:blip r:embed="rId3">
-            <a:extLst>
-              <a:ext uri="{28A0092B-C50C-407E-A947-70E740481C1C}">
-                <a14:useLocalDpi xmlns:a14="http://schemas.microsoft.com/office/drawing/2010/main" val="0"/>
-              </a:ext>
-            </a:extLst>
-          </a:blip>
-          <a:stretch>
-            <a:fillRect/>
-          </a:stretch>
-        </p:blipFill>
-        <p:spPr>
-          <a:xfrm>
-            <a:off x="9780086" y="1500"/>
-            <a:ext cx="2249850" cy="1062337"/>
-          </a:xfrm>
-          <a:prstGeom prst="rect">
-            <a:avLst/>
-          </a:prstGeom>
-        </p:spPr>
-      </p:pic>
+              </a:defRPr>
+            </a:pPr>
+            <a:r>
+              <a:t>End-to-end transparency: verified bank credits with official PFMS UTR references directly into Aadhaar-seeded accounts, eliminating middleman leakages.</a:t>
+            </a:r>
+          </a:p>
+        </p:txBody>
+      </p:sp>
     </p:spTree>
     <p:extLst>
       <p:ext uri="{BB962C8B-B14F-4D97-AF65-F5344CB8AC3E}">
-        <p14:creationId xmlns:p14="http://schemas.microsoft.com/office/powerpoint/2010/main" val="1588084416"/>
+        <p14:creationId xmlns:p14="http://schemas.microsoft.com/office/powerpoint/2010/main" val="3916788613"/>
       </p:ext>
     </p:extLst>
   </p:cSld>

</xml_diff>